<commit_message>
Rework the lifecycle slide: drop the forced stage mapping, open up the ring
The previous version pinned each of the eight chain stages onto exactly one
SDLC phase. That mapping does not exist: AI Memory is the pattern library
feeding every phase, not a design activity, and Compliance is a gate rather
than a phase. Forcing it produced "Design — 04 Compliance · 05 AI Memory",
which is wrong.

The right column now names one agent per phase with what it does, so the
slide makes its own claim instead of cross-referencing a diagram it does
not fit. Descriptions are held to a single line each, measured against the
column width rather than estimated.

The ring grows from r=170 to r=215 with 88px nodes and larger labels, so
the nodes, gates and arrowheads no longer crowd each other.

Co-Authored-By: Claude Opus 5 <noreply@anthropic.com>
Claude-Session: https://claude.ai/code/session_01NE7LjVDasJP9MMdSCEnLZ6
</commit_message>
<xml_diff>
--- a/deck/Pitch_Deck_AthenaRun_v2.pptx
+++ b/deck/Pitch_Deck_AthenaRun_v2.pptx
@@ -4379,7 +4379,7 @@
                 </a:solidFill>
                 <a:latin typeface="Poppins"/>
               </a:rPr>
-              <a:t> Six phases, eight stages, one chain.</a:t>
+              <a:t> Every phase has an agent.</a:t>
             </a:r>
           </a:p>
         </p:txBody>
@@ -4519,8 +4519,8 @@
         </p:nvSpPr>
         <p:spPr>
           <a:xfrm rot="1800000">
-            <a:off x="3987800" y="3136900"/>
-            <a:ext cx="1073150" cy="6350"/>
+            <a:off x="3841750" y="3098800"/>
+            <a:ext cx="1365250" cy="6350"/>
           </a:xfrm>
           <a:prstGeom prst="rect">
             <a:avLst/>
@@ -4563,8 +4563,8 @@
         </p:nvSpPr>
         <p:spPr>
           <a:xfrm rot="7200000">
-            <a:off x="4711700" y="3225800"/>
-            <a:ext cx="76200" cy="76200"/>
+            <a:off x="4787900" y="3232150"/>
+            <a:ext cx="88900" cy="88900"/>
           </a:xfrm>
           <a:prstGeom prst="triangle">
             <a:avLst/>
@@ -4607,8 +4607,8 @@
         </p:nvSpPr>
         <p:spPr>
           <a:xfrm>
-            <a:off x="4483100" y="3092450"/>
-            <a:ext cx="88900" cy="88900"/>
+            <a:off x="4476750" y="3048000"/>
+            <a:ext cx="101600" cy="101600"/>
           </a:xfrm>
           <a:prstGeom prst="diamond">
             <a:avLst/>
@@ -4651,8 +4651,8 @@
         </p:nvSpPr>
         <p:spPr>
           <a:xfrm rot="5400000">
-            <a:off x="4457700" y="3943350"/>
-            <a:ext cx="1079500" cy="6350"/>
+            <a:off x="4432300" y="4121150"/>
+            <a:ext cx="1365250" cy="6350"/>
           </a:xfrm>
           <a:prstGeom prst="rect">
             <a:avLst/>
@@ -4695,8 +4695,8 @@
         </p:nvSpPr>
         <p:spPr>
           <a:xfrm rot="10800000">
-            <a:off x="4959350" y="4165600"/>
-            <a:ext cx="76200" cy="76200"/>
+            <a:off x="5073650" y="4432300"/>
+            <a:ext cx="88900" cy="88900"/>
           </a:xfrm>
           <a:prstGeom prst="triangle">
             <a:avLst/>
@@ -4739,8 +4739,8 @@
         </p:nvSpPr>
         <p:spPr>
           <a:xfrm>
-            <a:off x="4953000" y="3905250"/>
-            <a:ext cx="88900" cy="88900"/>
+            <a:off x="5067300" y="4076700"/>
+            <a:ext cx="101600" cy="101600"/>
           </a:xfrm>
           <a:prstGeom prst="diamond">
             <a:avLst/>
@@ -4783,8 +4783,8 @@
         </p:nvSpPr>
         <p:spPr>
           <a:xfrm rot="9000000">
-            <a:off x="3987800" y="4756150"/>
-            <a:ext cx="1073150" cy="6350"/>
+            <a:off x="3841750" y="5143500"/>
+            <a:ext cx="1365250" cy="6350"/>
           </a:xfrm>
           <a:prstGeom prst="rect">
             <a:avLst/>
@@ -4827,8 +4827,8 @@
         </p:nvSpPr>
         <p:spPr>
           <a:xfrm rot="14400000">
-            <a:off x="4267200" y="4845050"/>
-            <a:ext cx="76200" cy="76200"/>
+            <a:off x="4171950" y="5283200"/>
+            <a:ext cx="88900" cy="88900"/>
           </a:xfrm>
           <a:prstGeom prst="triangle">
             <a:avLst/>
@@ -4871,8 +4871,8 @@
         </p:nvSpPr>
         <p:spPr>
           <a:xfrm>
-            <a:off x="4483100" y="4711700"/>
-            <a:ext cx="88900" cy="88900"/>
+            <a:off x="4476750" y="5099050"/>
+            <a:ext cx="101600" cy="101600"/>
           </a:xfrm>
           <a:prstGeom prst="diamond">
             <a:avLst/>
@@ -4915,8 +4915,8 @@
         </p:nvSpPr>
         <p:spPr>
           <a:xfrm rot="12600000">
-            <a:off x="3054350" y="4756150"/>
-            <a:ext cx="1079500" cy="6350"/>
+            <a:off x="2660650" y="5143500"/>
+            <a:ext cx="1365250" cy="6350"/>
           </a:xfrm>
           <a:prstGeom prst="rect">
             <a:avLst/>
@@ -4959,8 +4959,8 @@
         </p:nvSpPr>
         <p:spPr>
           <a:xfrm rot="18000000">
-            <a:off x="3333750" y="4591050"/>
-            <a:ext cx="76200" cy="76200"/>
+            <a:off x="2990850" y="4927600"/>
+            <a:ext cx="88900" cy="88900"/>
           </a:xfrm>
           <a:prstGeom prst="triangle">
             <a:avLst/>
@@ -5003,8 +5003,8 @@
         </p:nvSpPr>
         <p:spPr>
           <a:xfrm>
-            <a:off x="3549650" y="4711700"/>
-            <a:ext cx="88900" cy="88900"/>
+            <a:off x="3289300" y="5099050"/>
+            <a:ext cx="101600" cy="101600"/>
           </a:xfrm>
           <a:prstGeom prst="diamond">
             <a:avLst/>
@@ -5047,8 +5047,8 @@
         </p:nvSpPr>
         <p:spPr>
           <a:xfrm rot="16200000">
-            <a:off x="2584450" y="3943350"/>
-            <a:ext cx="1079500" cy="6350"/>
+            <a:off x="2070100" y="4121150"/>
+            <a:ext cx="1365250" cy="6350"/>
           </a:xfrm>
           <a:prstGeom prst="rect">
             <a:avLst/>
@@ -5090,9 +5090,9 @@
           <p:nvPr/>
         </p:nvSpPr>
         <p:spPr>
-          <a:xfrm rot="0">
-            <a:off x="3086100" y="3651250"/>
-            <a:ext cx="76200" cy="76200"/>
+          <a:xfrm>
+            <a:off x="2705100" y="3727450"/>
+            <a:ext cx="88900" cy="88900"/>
           </a:xfrm>
           <a:prstGeom prst="triangle">
             <a:avLst/>
@@ -5135,8 +5135,8 @@
         </p:nvSpPr>
         <p:spPr>
           <a:xfrm>
-            <a:off x="3079750" y="3905250"/>
-            <a:ext cx="88900" cy="88900"/>
+            <a:off x="2698750" y="4076700"/>
+            <a:ext cx="101600" cy="101600"/>
           </a:xfrm>
           <a:prstGeom prst="diamond">
             <a:avLst/>
@@ -5179,8 +5179,8 @@
         </p:nvSpPr>
         <p:spPr>
           <a:xfrm rot="19800000">
-            <a:off x="3054350" y="3136900"/>
-            <a:ext cx="1073150" cy="6350"/>
+            <a:off x="2660650" y="3098800"/>
+            <a:ext cx="1365250" cy="6350"/>
           </a:xfrm>
           <a:prstGeom prst="rect">
             <a:avLst/>
@@ -5223,8 +5223,8 @@
         </p:nvSpPr>
         <p:spPr>
           <a:xfrm rot="3600000">
-            <a:off x="3778250" y="2971800"/>
-            <a:ext cx="76200" cy="76200"/>
+            <a:off x="3606800" y="2876550"/>
+            <a:ext cx="88900" cy="88900"/>
           </a:xfrm>
           <a:prstGeom prst="triangle">
             <a:avLst/>
@@ -5267,8 +5267,8 @@
         </p:nvSpPr>
         <p:spPr>
           <a:xfrm>
-            <a:off x="3549650" y="3092450"/>
-            <a:ext cx="88900" cy="88900"/>
+            <a:off x="3289300" y="3048000"/>
+            <a:ext cx="101600" cy="101600"/>
           </a:xfrm>
           <a:prstGeom prst="diamond">
             <a:avLst/>
@@ -5311,8 +5311,8 @@
         </p:nvSpPr>
         <p:spPr>
           <a:xfrm>
-            <a:off x="3835400" y="2641600"/>
-            <a:ext cx="457200" cy="457200"/>
+            <a:off x="3657600" y="2482850"/>
+            <a:ext cx="558800" cy="558800"/>
           </a:xfrm>
           <a:prstGeom prst="ellipse">
             <a:avLst/>
@@ -5357,8 +5357,8 @@
         </p:nvSpPr>
         <p:spPr>
           <a:xfrm>
-            <a:off x="3810000" y="2774950"/>
-            <a:ext cx="508000" cy="190500"/>
+            <a:off x="3683000" y="2660650"/>
+            <a:ext cx="508000" cy="203200"/>
           </a:xfrm>
           <a:prstGeom prst="rect">
             <a:avLst/>
@@ -5373,7 +5373,7 @@
           <a:p>
             <a:pPr algn="ctr"/>
             <a:r>
-              <a:rPr sz="1300" b="0" spc="80">
+              <a:rPr sz="1400" b="0" spc="80">
                 <a:solidFill>
                   <a:srgbClr val="9A9AA2"/>
                 </a:solidFill>
@@ -5392,8 +5392,8 @@
         </p:nvSpPr>
         <p:spPr>
           <a:xfrm>
-            <a:off x="4768850" y="3181350"/>
-            <a:ext cx="457200" cy="457200"/>
+            <a:off x="4838700" y="3162300"/>
+            <a:ext cx="558800" cy="558800"/>
           </a:xfrm>
           <a:prstGeom prst="ellipse">
             <a:avLst/>
@@ -5438,8 +5438,8 @@
         </p:nvSpPr>
         <p:spPr>
           <a:xfrm>
-            <a:off x="4743450" y="3314700"/>
-            <a:ext cx="508000" cy="190500"/>
+            <a:off x="4864100" y="3340100"/>
+            <a:ext cx="508000" cy="203200"/>
           </a:xfrm>
           <a:prstGeom prst="rect">
             <a:avLst/>
@@ -5454,7 +5454,7 @@
           <a:p>
             <a:pPr algn="ctr"/>
             <a:r>
-              <a:rPr sz="1300" b="0" spc="80">
+              <a:rPr sz="1400" b="0" spc="80">
                 <a:solidFill>
                   <a:srgbClr val="9A9AA2"/>
                 </a:solidFill>
@@ -5473,8 +5473,8 @@
         </p:nvSpPr>
         <p:spPr>
           <a:xfrm>
-            <a:off x="4768850" y="4260850"/>
-            <a:ext cx="457200" cy="457200"/>
+            <a:off x="4838700" y="4527550"/>
+            <a:ext cx="558800" cy="558800"/>
           </a:xfrm>
           <a:prstGeom prst="ellipse">
             <a:avLst/>
@@ -5519,8 +5519,8 @@
         </p:nvSpPr>
         <p:spPr>
           <a:xfrm>
-            <a:off x="4743450" y="4394200"/>
-            <a:ext cx="508000" cy="190500"/>
+            <a:off x="4864100" y="4705350"/>
+            <a:ext cx="508000" cy="203200"/>
           </a:xfrm>
           <a:prstGeom prst="rect">
             <a:avLst/>
@@ -5535,7 +5535,7 @@
           <a:p>
             <a:pPr algn="ctr"/>
             <a:r>
-              <a:rPr sz="1300" b="0" spc="80">
+              <a:rPr sz="1400" b="0" spc="80">
                 <a:solidFill>
                   <a:srgbClr val="9A9AA2"/>
                 </a:solidFill>
@@ -5554,8 +5554,8 @@
         </p:nvSpPr>
         <p:spPr>
           <a:xfrm>
-            <a:off x="3835400" y="4800600"/>
-            <a:ext cx="457200" cy="457200"/>
+            <a:off x="3657600" y="5213350"/>
+            <a:ext cx="558800" cy="558800"/>
           </a:xfrm>
           <a:prstGeom prst="ellipse">
             <a:avLst/>
@@ -5600,8 +5600,8 @@
         </p:nvSpPr>
         <p:spPr>
           <a:xfrm>
-            <a:off x="3810000" y="4933950"/>
-            <a:ext cx="508000" cy="190500"/>
+            <a:off x="3683000" y="5391150"/>
+            <a:ext cx="508000" cy="203200"/>
           </a:xfrm>
           <a:prstGeom prst="rect">
             <a:avLst/>
@@ -5616,7 +5616,7 @@
           <a:p>
             <a:pPr algn="ctr"/>
             <a:r>
-              <a:rPr sz="1300" b="0" spc="80">
+              <a:rPr sz="1400" b="0" spc="80">
                 <a:solidFill>
                   <a:srgbClr val="9A9AA2"/>
                 </a:solidFill>
@@ -5635,8 +5635,8 @@
         </p:nvSpPr>
         <p:spPr>
           <a:xfrm>
-            <a:off x="2895600" y="4260850"/>
-            <a:ext cx="457200" cy="457200"/>
+            <a:off x="2470150" y="4527550"/>
+            <a:ext cx="558800" cy="558800"/>
           </a:xfrm>
           <a:prstGeom prst="ellipse">
             <a:avLst/>
@@ -5681,8 +5681,8 @@
         </p:nvSpPr>
         <p:spPr>
           <a:xfrm>
-            <a:off x="2870200" y="4394200"/>
-            <a:ext cx="508000" cy="190500"/>
+            <a:off x="2495550" y="4705350"/>
+            <a:ext cx="508000" cy="203200"/>
           </a:xfrm>
           <a:prstGeom prst="rect">
             <a:avLst/>
@@ -5697,7 +5697,7 @@
           <a:p>
             <a:pPr algn="ctr"/>
             <a:r>
-              <a:rPr sz="1300" b="0" spc="80">
+              <a:rPr sz="1400" b="0" spc="80">
                 <a:solidFill>
                   <a:srgbClr val="9A9AA2"/>
                 </a:solidFill>
@@ -5716,8 +5716,8 @@
         </p:nvSpPr>
         <p:spPr>
           <a:xfrm>
-            <a:off x="2895600" y="3181350"/>
-            <a:ext cx="457200" cy="457200"/>
+            <a:off x="2470150" y="3162300"/>
+            <a:ext cx="558800" cy="558800"/>
           </a:xfrm>
           <a:prstGeom prst="ellipse">
             <a:avLst/>
@@ -5762,8 +5762,8 @@
         </p:nvSpPr>
         <p:spPr>
           <a:xfrm>
-            <a:off x="2870200" y="3314700"/>
-            <a:ext cx="508000" cy="190500"/>
+            <a:off x="2495550" y="3340100"/>
+            <a:ext cx="508000" cy="203200"/>
           </a:xfrm>
           <a:prstGeom prst="rect">
             <a:avLst/>
@@ -5778,7 +5778,7 @@
           <a:p>
             <a:pPr algn="ctr"/>
             <a:r>
-              <a:rPr sz="1300" b="0" spc="80">
+              <a:rPr sz="1400" b="0" spc="80">
                 <a:solidFill>
                   <a:srgbClr val="9A9AA2"/>
                 </a:solidFill>
@@ -5797,8 +5797,8 @@
         </p:nvSpPr>
         <p:spPr>
           <a:xfrm>
-            <a:off x="2984500" y="2349500"/>
-            <a:ext cx="2159000" cy="203200"/>
+            <a:off x="2667000" y="2178050"/>
+            <a:ext cx="2540000" cy="215900"/>
           </a:xfrm>
           <a:prstGeom prst="rect">
             <a:avLst/>
@@ -5813,7 +5813,7 @@
           <a:p>
             <a:pPr algn="ctr"/>
             <a:r>
-              <a:rPr sz="1700" b="0">
+              <a:rPr sz="1800" b="0">
                 <a:solidFill>
                   <a:srgbClr val="ECECEE"/>
                 </a:solidFill>
@@ -5832,8 +5832,8 @@
         </p:nvSpPr>
         <p:spPr>
           <a:xfrm>
-            <a:off x="5340350" y="3308350"/>
-            <a:ext cx="1905000" cy="203200"/>
+            <a:off x="5537200" y="3333750"/>
+            <a:ext cx="2032000" cy="215900"/>
           </a:xfrm>
           <a:prstGeom prst="rect">
             <a:avLst/>
@@ -5848,7 +5848,7 @@
           <a:p>
             <a:pPr algn="l"/>
             <a:r>
-              <a:rPr sz="1700" b="0">
+              <a:rPr sz="1800" b="0">
                 <a:solidFill>
                   <a:srgbClr val="ECECEE"/>
                 </a:solidFill>
@@ -5867,8 +5867,8 @@
         </p:nvSpPr>
         <p:spPr>
           <a:xfrm>
-            <a:off x="5340350" y="4387850"/>
-            <a:ext cx="1905000" cy="203200"/>
+            <a:off x="5537200" y="4699000"/>
+            <a:ext cx="2032000" cy="215900"/>
           </a:xfrm>
           <a:prstGeom prst="rect">
             <a:avLst/>
@@ -5883,7 +5883,7 @@
           <a:p>
             <a:pPr algn="l"/>
             <a:r>
-              <a:rPr sz="1700" b="0">
+              <a:rPr sz="1800" b="0">
                 <a:solidFill>
                   <a:srgbClr val="ECECEE"/>
                 </a:solidFill>
@@ -5902,8 +5902,8 @@
         </p:nvSpPr>
         <p:spPr>
           <a:xfrm>
-            <a:off x="2984500" y="5359400"/>
-            <a:ext cx="2159000" cy="203200"/>
+            <a:off x="2667000" y="5873750"/>
+            <a:ext cx="2540000" cy="215900"/>
           </a:xfrm>
           <a:prstGeom prst="rect">
             <a:avLst/>
@@ -5918,7 +5918,7 @@
           <a:p>
             <a:pPr algn="ctr"/>
             <a:r>
-              <a:rPr sz="1700" b="0">
+              <a:rPr sz="1800" b="0">
                 <a:solidFill>
                   <a:srgbClr val="ECECEE"/>
                 </a:solidFill>
@@ -5937,8 +5937,8 @@
         </p:nvSpPr>
         <p:spPr>
           <a:xfrm>
-            <a:off x="876300" y="4387850"/>
-            <a:ext cx="1905000" cy="203200"/>
+            <a:off x="298450" y="4699000"/>
+            <a:ext cx="2032000" cy="215900"/>
           </a:xfrm>
           <a:prstGeom prst="rect">
             <a:avLst/>
@@ -5953,7 +5953,7 @@
           <a:p>
             <a:pPr algn="r"/>
             <a:r>
-              <a:rPr sz="1700" b="0">
+              <a:rPr sz="1800" b="0">
                 <a:solidFill>
                   <a:srgbClr val="ECECEE"/>
                 </a:solidFill>
@@ -5972,8 +5972,8 @@
         </p:nvSpPr>
         <p:spPr>
           <a:xfrm>
-            <a:off x="876300" y="3308350"/>
-            <a:ext cx="1905000" cy="203200"/>
+            <a:off x="298450" y="3333750"/>
+            <a:ext cx="2032000" cy="215900"/>
           </a:xfrm>
           <a:prstGeom prst="rect">
             <a:avLst/>
@@ -5988,7 +5988,7 @@
           <a:p>
             <a:pPr algn="r"/>
             <a:r>
-              <a:rPr sz="1700" b="0">
+              <a:rPr sz="1800" b="0">
                 <a:solidFill>
                   <a:srgbClr val="ECECEE"/>
                 </a:solidFill>
@@ -6007,8 +6007,8 @@
         </p:nvSpPr>
         <p:spPr>
           <a:xfrm>
-            <a:off x="3048000" y="3784600"/>
-            <a:ext cx="2032000" cy="152400"/>
+            <a:off x="2667000" y="3937000"/>
+            <a:ext cx="2540000" cy="165100"/>
           </a:xfrm>
           <a:prstGeom prst="rect">
             <a:avLst/>
@@ -6023,7 +6023,7 @@
           <a:p>
             <a:pPr algn="ctr"/>
             <a:r>
-              <a:rPr sz="1000" b="0" spc="300">
+              <a:rPr sz="1000" b="0" spc="200">
                 <a:solidFill>
                   <a:srgbClr val="9A9AA2"/>
                 </a:solidFill>
@@ -6042,8 +6042,8 @@
         </p:nvSpPr>
         <p:spPr>
           <a:xfrm>
-            <a:off x="3048000" y="3962400"/>
-            <a:ext cx="2032000" cy="215900"/>
+            <a:off x="2667000" y="4140200"/>
+            <a:ext cx="2540000" cy="241300"/>
           </a:xfrm>
           <a:prstGeom prst="rect">
             <a:avLst/>
@@ -6058,7 +6058,7 @@
           <a:p>
             <a:pPr algn="ctr"/>
             <a:r>
-              <a:rPr sz="1900" b="0">
+              <a:rPr sz="2100" b="0">
                 <a:solidFill>
                   <a:srgbClr val="ECECEE"/>
                 </a:solidFill>
@@ -6071,14 +6071,513 @@
       </p:sp>
       <p:sp>
         <p:nvSpPr>
-          <p:cNvPr id="45" name="Diamond 44"/>
+          <p:cNvPr id="45" name="Rectangle 44"/>
           <p:cNvSpPr/>
           <p:nvPr/>
         </p:nvSpPr>
         <p:spPr>
           <a:xfrm>
-            <a:off x="2508250" y="5924550"/>
-            <a:ext cx="88900" cy="88900"/>
+            <a:off x="6921500" y="2095500"/>
+            <a:ext cx="6350" cy="3810000"/>
+          </a:xfrm>
+          <a:prstGeom prst="rect">
+            <a:avLst/>
+          </a:prstGeom>
+          <a:solidFill>
+            <a:srgbClr val="1F1F22"/>
+          </a:solidFill>
+          <a:ln>
+            <a:noFill/>
+          </a:ln>
+          <a:effectLst/>
+        </p:spPr>
+        <p:style>
+          <a:lnRef idx="1">
+            <a:schemeClr val="accent1"/>
+          </a:lnRef>
+          <a:fillRef idx="3">
+            <a:schemeClr val="accent1"/>
+          </a:fillRef>
+          <a:effectRef idx="2">
+            <a:schemeClr val="accent1"/>
+          </a:effectRef>
+          <a:fontRef idx="minor">
+            <a:schemeClr val="lt1"/>
+          </a:fontRef>
+        </p:style>
+        <p:txBody>
+          <a:bodyPr rtlCol="0" anchor="ctr"/>
+          <a:lstStyle/>
+          <a:p>
+            <a:pPr algn="ctr"/>
+          </a:p>
+        </p:txBody>
+      </p:sp>
+      <p:sp>
+        <p:nvSpPr>
+          <p:cNvPr id="46" name="TextBox 45"/>
+          <p:cNvSpPr txBox="1"/>
+          <p:nvPr/>
+        </p:nvSpPr>
+        <p:spPr>
+          <a:xfrm>
+            <a:off x="7302500" y="2184400"/>
+            <a:ext cx="4445000" cy="165100"/>
+          </a:xfrm>
+          <a:prstGeom prst="rect">
+            <a:avLst/>
+          </a:prstGeom>
+          <a:noFill/>
+        </p:spPr>
+        <p:txBody>
+          <a:bodyPr wrap="square" lIns="0" rIns="0" tIns="0" bIns="0" anchor="ctr">
+            <a:spAutoFit/>
+          </a:bodyPr>
+          <a:lstStyle/>
+          <a:p>
+            <a:pPr algn="l"/>
+            <a:r>
+              <a:rPr sz="1100" b="0" spc="250">
+                <a:solidFill>
+                  <a:srgbClr val="9A9AA2"/>
+                </a:solidFill>
+                <a:latin typeface="Courier New"/>
+              </a:rPr>
+              <a:t>ONE AGENT PER PHASE</a:t>
+            </a:r>
+          </a:p>
+        </p:txBody>
+      </p:sp>
+      <p:sp>
+        <p:nvSpPr>
+          <p:cNvPr id="47" name="TextBox 46"/>
+          <p:cNvSpPr txBox="1"/>
+          <p:nvPr/>
+        </p:nvSpPr>
+        <p:spPr>
+          <a:xfrm>
+            <a:off x="7302500" y="2540000"/>
+            <a:ext cx="4184650" cy="190500"/>
+          </a:xfrm>
+          <a:prstGeom prst="rect">
+            <a:avLst/>
+          </a:prstGeom>
+          <a:noFill/>
+        </p:spPr>
+        <p:txBody>
+          <a:bodyPr wrap="square" lIns="0" rIns="0" tIns="0" bIns="0" anchor="ctr">
+            <a:spAutoFit/>
+          </a:bodyPr>
+          <a:lstStyle/>
+          <a:p>
+            <a:pPr algn="l"/>
+            <a:r>
+              <a:rPr sz="1600" b="0">
+                <a:solidFill>
+                  <a:srgbClr val="ECECEE"/>
+                </a:solidFill>
+                <a:latin typeface="Poppins"/>
+              </a:rPr>
+              <a:t>Planning agent</a:t>
+            </a:r>
+          </a:p>
+        </p:txBody>
+      </p:sp>
+      <p:sp>
+        <p:nvSpPr>
+          <p:cNvPr id="48" name="TextBox 47"/>
+          <p:cNvSpPr txBox="1"/>
+          <p:nvPr/>
+        </p:nvSpPr>
+        <p:spPr>
+          <a:xfrm>
+            <a:off x="7302500" y="2755900"/>
+            <a:ext cx="4184650" cy="190500"/>
+          </a:xfrm>
+          <a:prstGeom prst="rect">
+            <a:avLst/>
+          </a:prstGeom>
+          <a:noFill/>
+        </p:spPr>
+        <p:txBody>
+          <a:bodyPr wrap="square" lIns="0" rIns="0" tIns="0" bIns="0" anchor="ctr">
+            <a:spAutoFit/>
+          </a:bodyPr>
+          <a:lstStyle/>
+          <a:p>
+            <a:pPr algn="l"/>
+            <a:r>
+              <a:rPr sz="1250" b="0">
+                <a:solidFill>
+                  <a:srgbClr val="9A9AA2"/>
+                </a:solidFill>
+                <a:latin typeface="Poppins"/>
+              </a:rPr>
+              <a:t>scope from first conversation, feasibility and fit</a:t>
+            </a:r>
+          </a:p>
+        </p:txBody>
+      </p:sp>
+      <p:sp>
+        <p:nvSpPr>
+          <p:cNvPr id="49" name="TextBox 48"/>
+          <p:cNvSpPr txBox="1"/>
+          <p:nvPr/>
+        </p:nvSpPr>
+        <p:spPr>
+          <a:xfrm>
+            <a:off x="7302500" y="3098800"/>
+            <a:ext cx="4184650" cy="190500"/>
+          </a:xfrm>
+          <a:prstGeom prst="rect">
+            <a:avLst/>
+          </a:prstGeom>
+          <a:noFill/>
+        </p:spPr>
+        <p:txBody>
+          <a:bodyPr wrap="square" lIns="0" rIns="0" tIns="0" bIns="0" anchor="ctr">
+            <a:spAutoFit/>
+          </a:bodyPr>
+          <a:lstStyle/>
+          <a:p>
+            <a:pPr algn="l"/>
+            <a:r>
+              <a:rPr sz="1600" b="0">
+                <a:solidFill>
+                  <a:srgbClr val="ECECEE"/>
+                </a:solidFill>
+                <a:latin typeface="Poppins"/>
+              </a:rPr>
+              <a:t>Analysis agent</a:t>
+            </a:r>
+          </a:p>
+        </p:txBody>
+      </p:sp>
+      <p:sp>
+        <p:nvSpPr>
+          <p:cNvPr id="50" name="TextBox 49"/>
+          <p:cNvSpPr txBox="1"/>
+          <p:nvPr/>
+        </p:nvSpPr>
+        <p:spPr>
+          <a:xfrm>
+            <a:off x="7302500" y="3314700"/>
+            <a:ext cx="4184650" cy="190500"/>
+          </a:xfrm>
+          <a:prstGeom prst="rect">
+            <a:avLst/>
+          </a:prstGeom>
+          <a:noFill/>
+        </p:spPr>
+        <p:txBody>
+          <a:bodyPr wrap="square" lIns="0" rIns="0" tIns="0" bIns="0" anchor="ctr">
+            <a:spAutoFit/>
+          </a:bodyPr>
+          <a:lstStyle/>
+          <a:p>
+            <a:pPr algn="l"/>
+            <a:r>
+              <a:rPr sz="1250" b="0">
+                <a:solidFill>
+                  <a:srgbClr val="9A9AA2"/>
+                </a:solidFill>
+                <a:latin typeface="Poppins"/>
+              </a:rPr>
+              <a:t>cited, deep research into the requirements</a:t>
+            </a:r>
+          </a:p>
+        </p:txBody>
+      </p:sp>
+      <p:sp>
+        <p:nvSpPr>
+          <p:cNvPr id="51" name="TextBox 50"/>
+          <p:cNvSpPr txBox="1"/>
+          <p:nvPr/>
+        </p:nvSpPr>
+        <p:spPr>
+          <a:xfrm>
+            <a:off x="7302500" y="3657600"/>
+            <a:ext cx="4184650" cy="190500"/>
+          </a:xfrm>
+          <a:prstGeom prst="rect">
+            <a:avLst/>
+          </a:prstGeom>
+          <a:noFill/>
+        </p:spPr>
+        <p:txBody>
+          <a:bodyPr wrap="square" lIns="0" rIns="0" tIns="0" bIns="0" anchor="ctr">
+            <a:spAutoFit/>
+          </a:bodyPr>
+          <a:lstStyle/>
+          <a:p>
+            <a:pPr algn="l"/>
+            <a:r>
+              <a:rPr sz="1600" b="0">
+                <a:solidFill>
+                  <a:srgbClr val="ECECEE"/>
+                </a:solidFill>
+                <a:latin typeface="Poppins"/>
+              </a:rPr>
+              <a:t>Design agent</a:t>
+            </a:r>
+          </a:p>
+        </p:txBody>
+      </p:sp>
+      <p:sp>
+        <p:nvSpPr>
+          <p:cNvPr id="52" name="TextBox 51"/>
+          <p:cNvSpPr txBox="1"/>
+          <p:nvPr/>
+        </p:nvSpPr>
+        <p:spPr>
+          <a:xfrm>
+            <a:off x="7302500" y="3873500"/>
+            <a:ext cx="4184650" cy="190500"/>
+          </a:xfrm>
+          <a:prstGeom prst="rect">
+            <a:avLst/>
+          </a:prstGeom>
+          <a:noFill/>
+        </p:spPr>
+        <p:txBody>
+          <a:bodyPr wrap="square" lIns="0" rIns="0" tIns="0" bIns="0" anchor="ctr">
+            <a:spAutoFit/>
+          </a:bodyPr>
+          <a:lstStyle/>
+          <a:p>
+            <a:pPr algn="l"/>
+            <a:r>
+              <a:rPr sz="1250" b="0">
+                <a:solidFill>
+                  <a:srgbClr val="9A9AA2"/>
+                </a:solidFill>
+                <a:latin typeface="Poppins"/>
+              </a:rPr>
+              <a:t>architecture, checked at the compliance gate</a:t>
+            </a:r>
+          </a:p>
+        </p:txBody>
+      </p:sp>
+      <p:sp>
+        <p:nvSpPr>
+          <p:cNvPr id="53" name="TextBox 52"/>
+          <p:cNvSpPr txBox="1"/>
+          <p:nvPr/>
+        </p:nvSpPr>
+        <p:spPr>
+          <a:xfrm>
+            <a:off x="7302500" y="4216400"/>
+            <a:ext cx="4184650" cy="190500"/>
+          </a:xfrm>
+          <a:prstGeom prst="rect">
+            <a:avLst/>
+          </a:prstGeom>
+          <a:noFill/>
+        </p:spPr>
+        <p:txBody>
+          <a:bodyPr wrap="square" lIns="0" rIns="0" tIns="0" bIns="0" anchor="ctr">
+            <a:spAutoFit/>
+          </a:bodyPr>
+          <a:lstStyle/>
+          <a:p>
+            <a:pPr algn="l"/>
+            <a:r>
+              <a:rPr sz="1600" b="0">
+                <a:solidFill>
+                  <a:srgbClr val="ECECEE"/>
+                </a:solidFill>
+                <a:latin typeface="Poppins"/>
+              </a:rPr>
+              <a:t>Build agent</a:t>
+            </a:r>
+          </a:p>
+        </p:txBody>
+      </p:sp>
+      <p:sp>
+        <p:nvSpPr>
+          <p:cNvPr id="54" name="TextBox 53"/>
+          <p:cNvSpPr txBox="1"/>
+          <p:nvPr/>
+        </p:nvSpPr>
+        <p:spPr>
+          <a:xfrm>
+            <a:off x="7302500" y="4432300"/>
+            <a:ext cx="4184650" cy="190500"/>
+          </a:xfrm>
+          <a:prstGeom prst="rect">
+            <a:avLst/>
+          </a:prstGeom>
+          <a:noFill/>
+        </p:spPr>
+        <p:txBody>
+          <a:bodyPr wrap="square" lIns="0" rIns="0" tIns="0" bIns="0" anchor="ctr">
+            <a:spAutoFit/>
+          </a:bodyPr>
+          <a:lstStyle/>
+          <a:p>
+            <a:pPr algn="l"/>
+            <a:r>
+              <a:rPr sz="1250" b="0">
+                <a:solidFill>
+                  <a:srgbClr val="9A9AA2"/>
+                </a:solidFill>
+                <a:latin typeface="Poppins"/>
+              </a:rPr>
+              <a:t>implementation with code review</a:t>
+            </a:r>
+          </a:p>
+        </p:txBody>
+      </p:sp>
+      <p:sp>
+        <p:nvSpPr>
+          <p:cNvPr id="55" name="TextBox 54"/>
+          <p:cNvSpPr txBox="1"/>
+          <p:nvPr/>
+        </p:nvSpPr>
+        <p:spPr>
+          <a:xfrm>
+            <a:off x="7302500" y="4775200"/>
+            <a:ext cx="4184650" cy="190500"/>
+          </a:xfrm>
+          <a:prstGeom prst="rect">
+            <a:avLst/>
+          </a:prstGeom>
+          <a:noFill/>
+        </p:spPr>
+        <p:txBody>
+          <a:bodyPr wrap="square" lIns="0" rIns="0" tIns="0" bIns="0" anchor="ctr">
+            <a:spAutoFit/>
+          </a:bodyPr>
+          <a:lstStyle/>
+          <a:p>
+            <a:pPr algn="l"/>
+            <a:r>
+              <a:rPr sz="1600" b="0">
+                <a:solidFill>
+                  <a:srgbClr val="ECECEE"/>
+                </a:solidFill>
+                <a:latin typeface="Poppins"/>
+              </a:rPr>
+              <a:t>Test agent</a:t>
+            </a:r>
+          </a:p>
+        </p:txBody>
+      </p:sp>
+      <p:sp>
+        <p:nvSpPr>
+          <p:cNvPr id="56" name="TextBox 55"/>
+          <p:cNvSpPr txBox="1"/>
+          <p:nvPr/>
+        </p:nvSpPr>
+        <p:spPr>
+          <a:xfrm>
+            <a:off x="7302500" y="4991100"/>
+            <a:ext cx="4184650" cy="190500"/>
+          </a:xfrm>
+          <a:prstGeom prst="rect">
+            <a:avLst/>
+          </a:prstGeom>
+          <a:noFill/>
+        </p:spPr>
+        <p:txBody>
+          <a:bodyPr wrap="square" lIns="0" rIns="0" tIns="0" bIns="0" anchor="ctr">
+            <a:spAutoFit/>
+          </a:bodyPr>
+          <a:lstStyle/>
+          <a:p>
+            <a:pPr algn="l"/>
+            <a:r>
+              <a:rPr sz="1250" b="0">
+                <a:solidFill>
+                  <a:srgbClr val="9A9AA2"/>
+                </a:solidFill>
+                <a:latin typeface="Poppins"/>
+              </a:rPr>
+              <a:t>verification before the release approval</a:t>
+            </a:r>
+          </a:p>
+        </p:txBody>
+      </p:sp>
+      <p:sp>
+        <p:nvSpPr>
+          <p:cNvPr id="57" name="TextBox 56"/>
+          <p:cNvSpPr txBox="1"/>
+          <p:nvPr/>
+        </p:nvSpPr>
+        <p:spPr>
+          <a:xfrm>
+            <a:off x="7302500" y="5334000"/>
+            <a:ext cx="4184650" cy="190500"/>
+          </a:xfrm>
+          <a:prstGeom prst="rect">
+            <a:avLst/>
+          </a:prstGeom>
+          <a:noFill/>
+        </p:spPr>
+        <p:txBody>
+          <a:bodyPr wrap="square" lIns="0" rIns="0" tIns="0" bIns="0" anchor="ctr">
+            <a:spAutoFit/>
+          </a:bodyPr>
+          <a:lstStyle/>
+          <a:p>
+            <a:pPr algn="l"/>
+            <a:r>
+              <a:rPr sz="1600" b="0">
+                <a:solidFill>
+                  <a:srgbClr val="ECECEE"/>
+                </a:solidFill>
+                <a:latin typeface="Poppins"/>
+              </a:rPr>
+              <a:t>Operations agent</a:t>
+            </a:r>
+          </a:p>
+        </p:txBody>
+      </p:sp>
+      <p:sp>
+        <p:nvSpPr>
+          <p:cNvPr id="58" name="TextBox 57"/>
+          <p:cNvSpPr txBox="1"/>
+          <p:nvPr/>
+        </p:nvSpPr>
+        <p:spPr>
+          <a:xfrm>
+            <a:off x="7302500" y="5549900"/>
+            <a:ext cx="4184650" cy="190500"/>
+          </a:xfrm>
+          <a:prstGeom prst="rect">
+            <a:avLst/>
+          </a:prstGeom>
+          <a:noFill/>
+        </p:spPr>
+        <p:txBody>
+          <a:bodyPr wrap="square" lIns="0" rIns="0" tIns="0" bIns="0" anchor="ctr">
+            <a:spAutoFit/>
+          </a:bodyPr>
+          <a:lstStyle/>
+          <a:p>
+            <a:pPr algn="l"/>
+            <a:r>
+              <a:rPr sz="1250" b="0">
+                <a:solidFill>
+                  <a:srgbClr val="9A9AA2"/>
+                </a:solidFill>
+                <a:latin typeface="Poppins"/>
+              </a:rPr>
+              <a:t>monitoring, patterns back to the library</a:t>
+            </a:r>
+          </a:p>
+        </p:txBody>
+      </p:sp>
+      <p:sp>
+        <p:nvSpPr>
+          <p:cNvPr id="59" name="Diamond 58"/>
+          <p:cNvSpPr/>
+          <p:nvPr/>
+        </p:nvSpPr>
+        <p:spPr>
+          <a:xfrm>
+            <a:off x="7296150" y="5956300"/>
+            <a:ext cx="101600" cy="101600"/>
           </a:xfrm>
           <a:prstGeom prst="diamond">
             <a:avLst/>
@@ -6115,14 +6614,14 @@
       </p:sp>
       <p:sp>
         <p:nvSpPr>
-          <p:cNvPr id="46" name="TextBox 45"/>
-          <p:cNvSpPr txBox="1"/>
-          <p:nvPr/>
-        </p:nvSpPr>
-        <p:spPr>
-          <a:xfrm>
-            <a:off x="2679700" y="5892800"/>
-            <a:ext cx="3810000" cy="165100"/>
+          <p:cNvPr id="60" name="TextBox 59"/>
+          <p:cNvSpPr txBox="1"/>
+          <p:nvPr/>
+        </p:nvSpPr>
+        <p:spPr>
+          <a:xfrm>
+            <a:off x="7493000" y="5930900"/>
+            <a:ext cx="4064000" cy="165100"/>
           </a:xfrm>
           <a:prstGeom prst="rect">
             <a:avLst/>
@@ -6148,543 +6647,9 @@
           </a:p>
         </p:txBody>
       </p:sp>
-      <p:sp>
-        <p:nvSpPr>
-          <p:cNvPr id="47" name="Rectangle 46"/>
-          <p:cNvSpPr/>
-          <p:nvPr/>
-        </p:nvSpPr>
-        <p:spPr>
-          <a:xfrm>
-            <a:off x="6934200" y="2095500"/>
-            <a:ext cx="6350" cy="3619500"/>
-          </a:xfrm>
-          <a:prstGeom prst="rect">
-            <a:avLst/>
-          </a:prstGeom>
-          <a:solidFill>
-            <a:srgbClr val="1F1F22"/>
-          </a:solidFill>
-          <a:ln>
-            <a:noFill/>
-          </a:ln>
-          <a:effectLst/>
-        </p:spPr>
-        <p:style>
-          <a:lnRef idx="1">
-            <a:schemeClr val="accent1"/>
-          </a:lnRef>
-          <a:fillRef idx="3">
-            <a:schemeClr val="accent1"/>
-          </a:fillRef>
-          <a:effectRef idx="2">
-            <a:schemeClr val="accent1"/>
-          </a:effectRef>
-          <a:fontRef idx="minor">
-            <a:schemeClr val="lt1"/>
-          </a:fontRef>
-        </p:style>
-        <p:txBody>
-          <a:bodyPr rtlCol="0" anchor="ctr"/>
-          <a:lstStyle/>
-          <a:p>
-            <a:pPr algn="ctr"/>
-          </a:p>
-        </p:txBody>
-      </p:sp>
-      <p:sp>
-        <p:nvSpPr>
-          <p:cNvPr id="48" name="TextBox 47"/>
-          <p:cNvSpPr txBox="1"/>
-          <p:nvPr/>
-        </p:nvSpPr>
-        <p:spPr>
-          <a:xfrm>
-            <a:off x="7239000" y="2159000"/>
-            <a:ext cx="4445000" cy="165100"/>
-          </a:xfrm>
-          <a:prstGeom prst="rect">
-            <a:avLst/>
-          </a:prstGeom>
-          <a:noFill/>
-        </p:spPr>
-        <p:txBody>
-          <a:bodyPr wrap="square" lIns="0" rIns="0" tIns="0" bIns="0" anchor="ctr">
-            <a:spAutoFit/>
-          </a:bodyPr>
-          <a:lstStyle/>
-          <a:p>
-            <a:pPr algn="l"/>
-            <a:r>
-              <a:rPr sz="1100" b="0" spc="250">
-                <a:solidFill>
-                  <a:srgbClr val="9A9AA2"/>
-                </a:solidFill>
-                <a:latin typeface="Courier New"/>
-              </a:rPr>
-              <a:t>SDLC PHASE  ·  CHAIN STAGE</a:t>
-            </a:r>
-          </a:p>
-        </p:txBody>
-      </p:sp>
-      <p:sp>
-        <p:nvSpPr>
-          <p:cNvPr id="49" name="TextBox 48"/>
-          <p:cNvSpPr txBox="1"/>
-          <p:nvPr/>
-        </p:nvSpPr>
-        <p:spPr>
-          <a:xfrm>
-            <a:off x="7239000" y="2527300"/>
-            <a:ext cx="4248150" cy="190500"/>
-          </a:xfrm>
-          <a:prstGeom prst="rect">
-            <a:avLst/>
-          </a:prstGeom>
-          <a:noFill/>
-        </p:spPr>
-        <p:txBody>
-          <a:bodyPr wrap="square" lIns="0" rIns="0" tIns="0" bIns="0" anchor="ctr">
-            <a:spAutoFit/>
-          </a:bodyPr>
-          <a:lstStyle/>
-          <a:p>
-            <a:pPr algn="l"/>
-            <a:r>
-              <a:rPr sz="1600" b="0">
-                <a:solidFill>
-                  <a:srgbClr val="ECECEE"/>
-                </a:solidFill>
-                <a:latin typeface="Poppins"/>
-              </a:rPr>
-              <a:t>Planning</a:t>
-            </a:r>
-          </a:p>
-        </p:txBody>
-      </p:sp>
-      <p:sp>
-        <p:nvSpPr>
-          <p:cNvPr id="50" name="TextBox 49"/>
-          <p:cNvSpPr txBox="1"/>
-          <p:nvPr/>
-        </p:nvSpPr>
-        <p:spPr>
-          <a:xfrm>
-            <a:off x="7239000" y="2730500"/>
-            <a:ext cx="4248150" cy="165100"/>
-          </a:xfrm>
-          <a:prstGeom prst="rect">
-            <a:avLst/>
-          </a:prstGeom>
-          <a:noFill/>
-        </p:spPr>
-        <p:txBody>
-          <a:bodyPr wrap="square" lIns="0" rIns="0" tIns="0" bIns="0" anchor="ctr">
-            <a:spAutoFit/>
-          </a:bodyPr>
-          <a:lstStyle/>
-          <a:p>
-            <a:pPr algn="l"/>
-            <a:r>
-              <a:rPr sz="1100" b="0" spc="80">
-                <a:solidFill>
-                  <a:srgbClr val="9A9AA2"/>
-                </a:solidFill>
-                <a:latin typeface="Courier New"/>
-              </a:rPr>
-              <a:t>01 Discover  ·  02 Analyze</a:t>
-            </a:r>
-          </a:p>
-        </p:txBody>
-      </p:sp>
-      <p:sp>
-        <p:nvSpPr>
-          <p:cNvPr id="51" name="TextBox 50"/>
-          <p:cNvSpPr txBox="1"/>
-          <p:nvPr/>
-        </p:nvSpPr>
-        <p:spPr>
-          <a:xfrm>
-            <a:off x="7239000" y="3060700"/>
-            <a:ext cx="4248150" cy="190500"/>
-          </a:xfrm>
-          <a:prstGeom prst="rect">
-            <a:avLst/>
-          </a:prstGeom>
-          <a:noFill/>
-        </p:spPr>
-        <p:txBody>
-          <a:bodyPr wrap="square" lIns="0" rIns="0" tIns="0" bIns="0" anchor="ctr">
-            <a:spAutoFit/>
-          </a:bodyPr>
-          <a:lstStyle/>
-          <a:p>
-            <a:pPr algn="l"/>
-            <a:r>
-              <a:rPr sz="1600" b="0">
-                <a:solidFill>
-                  <a:srgbClr val="ECECEE"/>
-                </a:solidFill>
-                <a:latin typeface="Poppins"/>
-              </a:rPr>
-              <a:t>Analysis</a:t>
-            </a:r>
-          </a:p>
-        </p:txBody>
-      </p:sp>
-      <p:sp>
-        <p:nvSpPr>
-          <p:cNvPr id="52" name="TextBox 51"/>
-          <p:cNvSpPr txBox="1"/>
-          <p:nvPr/>
-        </p:nvSpPr>
-        <p:spPr>
-          <a:xfrm>
-            <a:off x="7239000" y="3263900"/>
-            <a:ext cx="4248150" cy="165100"/>
-          </a:xfrm>
-          <a:prstGeom prst="rect">
-            <a:avLst/>
-          </a:prstGeom>
-          <a:noFill/>
-        </p:spPr>
-        <p:txBody>
-          <a:bodyPr wrap="square" lIns="0" rIns="0" tIns="0" bIns="0" anchor="ctr">
-            <a:spAutoFit/>
-          </a:bodyPr>
-          <a:lstStyle/>
-          <a:p>
-            <a:pPr algn="l"/>
-            <a:r>
-              <a:rPr sz="1100" b="0" spc="80">
-                <a:solidFill>
-                  <a:srgbClr val="9A9AA2"/>
-                </a:solidFill>
-                <a:latin typeface="Courier New"/>
-              </a:rPr>
-              <a:t>03 Research</a:t>
-            </a:r>
-          </a:p>
-        </p:txBody>
-      </p:sp>
-      <p:sp>
-        <p:nvSpPr>
-          <p:cNvPr id="53" name="TextBox 52"/>
-          <p:cNvSpPr txBox="1"/>
-          <p:nvPr/>
-        </p:nvSpPr>
-        <p:spPr>
-          <a:xfrm>
-            <a:off x="7239000" y="3594100"/>
-            <a:ext cx="4248150" cy="190500"/>
-          </a:xfrm>
-          <a:prstGeom prst="rect">
-            <a:avLst/>
-          </a:prstGeom>
-          <a:noFill/>
-        </p:spPr>
-        <p:txBody>
-          <a:bodyPr wrap="square" lIns="0" rIns="0" tIns="0" bIns="0" anchor="ctr">
-            <a:spAutoFit/>
-          </a:bodyPr>
-          <a:lstStyle/>
-          <a:p>
-            <a:pPr algn="l"/>
-            <a:r>
-              <a:rPr sz="1600" b="0">
-                <a:solidFill>
-                  <a:srgbClr val="ECECEE"/>
-                </a:solidFill>
-                <a:latin typeface="Poppins"/>
-              </a:rPr>
-              <a:t>Design</a:t>
-            </a:r>
-          </a:p>
-        </p:txBody>
-      </p:sp>
-      <p:sp>
-        <p:nvSpPr>
-          <p:cNvPr id="54" name="TextBox 53"/>
-          <p:cNvSpPr txBox="1"/>
-          <p:nvPr/>
-        </p:nvSpPr>
-        <p:spPr>
-          <a:xfrm>
-            <a:off x="7239000" y="3797300"/>
-            <a:ext cx="4248150" cy="165100"/>
-          </a:xfrm>
-          <a:prstGeom prst="rect">
-            <a:avLst/>
-          </a:prstGeom>
-          <a:noFill/>
-        </p:spPr>
-        <p:txBody>
-          <a:bodyPr wrap="square" lIns="0" rIns="0" tIns="0" bIns="0" anchor="ctr">
-            <a:spAutoFit/>
-          </a:bodyPr>
-          <a:lstStyle/>
-          <a:p>
-            <a:pPr algn="l"/>
-            <a:r>
-              <a:rPr sz="1100" b="0" spc="80">
-                <a:solidFill>
-                  <a:srgbClr val="9A9AA2"/>
-                </a:solidFill>
-                <a:latin typeface="Courier New"/>
-              </a:rPr>
-              <a:t>04 Compliance  ·  05 AI Memory</a:t>
-            </a:r>
-          </a:p>
-        </p:txBody>
-      </p:sp>
-      <p:sp>
-        <p:nvSpPr>
-          <p:cNvPr id="55" name="TextBox 54"/>
-          <p:cNvSpPr txBox="1"/>
-          <p:nvPr/>
-        </p:nvSpPr>
-        <p:spPr>
-          <a:xfrm>
-            <a:off x="7239000" y="4127500"/>
-            <a:ext cx="4248150" cy="190500"/>
-          </a:xfrm>
-          <a:prstGeom prst="rect">
-            <a:avLst/>
-          </a:prstGeom>
-          <a:noFill/>
-        </p:spPr>
-        <p:txBody>
-          <a:bodyPr wrap="square" lIns="0" rIns="0" tIns="0" bIns="0" anchor="ctr">
-            <a:spAutoFit/>
-          </a:bodyPr>
-          <a:lstStyle/>
-          <a:p>
-            <a:pPr algn="l"/>
-            <a:r>
-              <a:rPr sz="1600" b="0">
-                <a:solidFill>
-                  <a:srgbClr val="ECECEE"/>
-                </a:solidFill>
-                <a:latin typeface="Poppins"/>
-              </a:rPr>
-              <a:t>Implementation</a:t>
-            </a:r>
-          </a:p>
-        </p:txBody>
-      </p:sp>
-      <p:sp>
-        <p:nvSpPr>
-          <p:cNvPr id="56" name="TextBox 55"/>
-          <p:cNvSpPr txBox="1"/>
-          <p:nvPr/>
-        </p:nvSpPr>
-        <p:spPr>
-          <a:xfrm>
-            <a:off x="7239000" y="4330700"/>
-            <a:ext cx="4248150" cy="165100"/>
-          </a:xfrm>
-          <a:prstGeom prst="rect">
-            <a:avLst/>
-          </a:prstGeom>
-          <a:noFill/>
-        </p:spPr>
-        <p:txBody>
-          <a:bodyPr wrap="square" lIns="0" rIns="0" tIns="0" bIns="0" anchor="ctr">
-            <a:spAutoFit/>
-          </a:bodyPr>
-          <a:lstStyle/>
-          <a:p>
-            <a:pPr algn="l"/>
-            <a:r>
-              <a:rPr sz="1100" b="0" spc="80">
-                <a:solidFill>
-                  <a:srgbClr val="9A9AA2"/>
-                </a:solidFill>
-                <a:latin typeface="Courier New"/>
-              </a:rPr>
-              <a:t>06 Build</a:t>
-            </a:r>
-          </a:p>
-        </p:txBody>
-      </p:sp>
-      <p:sp>
-        <p:nvSpPr>
-          <p:cNvPr id="57" name="TextBox 56"/>
-          <p:cNvSpPr txBox="1"/>
-          <p:nvPr/>
-        </p:nvSpPr>
-        <p:spPr>
-          <a:xfrm>
-            <a:off x="7239000" y="4660900"/>
-            <a:ext cx="4248150" cy="190500"/>
-          </a:xfrm>
-          <a:prstGeom prst="rect">
-            <a:avLst/>
-          </a:prstGeom>
-          <a:noFill/>
-        </p:spPr>
-        <p:txBody>
-          <a:bodyPr wrap="square" lIns="0" rIns="0" tIns="0" bIns="0" anchor="ctr">
-            <a:spAutoFit/>
-          </a:bodyPr>
-          <a:lstStyle/>
-          <a:p>
-            <a:pPr algn="l"/>
-            <a:r>
-              <a:rPr sz="1600" b="0">
-                <a:solidFill>
-                  <a:srgbClr val="ECECEE"/>
-                </a:solidFill>
-                <a:latin typeface="Poppins"/>
-              </a:rPr>
-              <a:t>Testing</a:t>
-            </a:r>
-          </a:p>
-        </p:txBody>
-      </p:sp>
-      <p:sp>
-        <p:nvSpPr>
-          <p:cNvPr id="58" name="TextBox 57"/>
-          <p:cNvSpPr txBox="1"/>
-          <p:nvPr/>
-        </p:nvSpPr>
-        <p:spPr>
-          <a:xfrm>
-            <a:off x="7239000" y="4864100"/>
-            <a:ext cx="4248150" cy="165100"/>
-          </a:xfrm>
-          <a:prstGeom prst="rect">
-            <a:avLst/>
-          </a:prstGeom>
-          <a:noFill/>
-        </p:spPr>
-        <p:txBody>
-          <a:bodyPr wrap="square" lIns="0" rIns="0" tIns="0" bIns="0" anchor="ctr">
-            <a:spAutoFit/>
-          </a:bodyPr>
-          <a:lstStyle/>
-          <a:p>
-            <a:pPr algn="l"/>
-            <a:r>
-              <a:rPr sz="1100" b="0" spc="80">
-                <a:solidFill>
-                  <a:srgbClr val="9A9AA2"/>
-                </a:solidFill>
-                <a:latin typeface="Courier New"/>
-              </a:rPr>
-              <a:t>07 Release</a:t>
-            </a:r>
-          </a:p>
-        </p:txBody>
-      </p:sp>
-      <p:sp>
-        <p:nvSpPr>
-          <p:cNvPr id="59" name="TextBox 58"/>
-          <p:cNvSpPr txBox="1"/>
-          <p:nvPr/>
-        </p:nvSpPr>
-        <p:spPr>
-          <a:xfrm>
-            <a:off x="7239000" y="5194300"/>
-            <a:ext cx="4248150" cy="190500"/>
-          </a:xfrm>
-          <a:prstGeom prst="rect">
-            <a:avLst/>
-          </a:prstGeom>
-          <a:noFill/>
-        </p:spPr>
-        <p:txBody>
-          <a:bodyPr wrap="square" lIns="0" rIns="0" tIns="0" bIns="0" anchor="ctr">
-            <a:spAutoFit/>
-          </a:bodyPr>
-          <a:lstStyle/>
-          <a:p>
-            <a:pPr algn="l"/>
-            <a:r>
-              <a:rPr sz="1600" b="0">
-                <a:solidFill>
-                  <a:srgbClr val="ECECEE"/>
-                </a:solidFill>
-                <a:latin typeface="Poppins"/>
-              </a:rPr>
-              <a:t>Maintenance</a:t>
-            </a:r>
-          </a:p>
-        </p:txBody>
-      </p:sp>
-      <p:sp>
-        <p:nvSpPr>
-          <p:cNvPr id="60" name="TextBox 59"/>
-          <p:cNvSpPr txBox="1"/>
-          <p:nvPr/>
-        </p:nvSpPr>
-        <p:spPr>
-          <a:xfrm>
-            <a:off x="7239000" y="5397500"/>
-            <a:ext cx="4248150" cy="165100"/>
-          </a:xfrm>
-          <a:prstGeom prst="rect">
-            <a:avLst/>
-          </a:prstGeom>
-          <a:noFill/>
-        </p:spPr>
-        <p:txBody>
-          <a:bodyPr wrap="square" lIns="0" rIns="0" tIns="0" bIns="0" anchor="ctr">
-            <a:spAutoFit/>
-          </a:bodyPr>
-          <a:lstStyle/>
-          <a:p>
-            <a:pPr algn="l"/>
-            <a:r>
-              <a:rPr sz="1100" b="0" spc="80">
-                <a:solidFill>
-                  <a:srgbClr val="9A9AA2"/>
-                </a:solidFill>
-                <a:latin typeface="Courier New"/>
-              </a:rPr>
-              <a:t>08 Operate</a:t>
-            </a:r>
-          </a:p>
-        </p:txBody>
-      </p:sp>
-      <p:sp>
-        <p:nvSpPr>
-          <p:cNvPr id="61" name="TextBox 60"/>
-          <p:cNvSpPr txBox="1"/>
-          <p:nvPr/>
-        </p:nvSpPr>
-        <p:spPr>
-          <a:xfrm>
-            <a:off x="7239000" y="5727700"/>
-            <a:ext cx="4248150" cy="165100"/>
-          </a:xfrm>
-          <a:prstGeom prst="rect">
-            <a:avLst/>
-          </a:prstGeom>
-          <a:noFill/>
-        </p:spPr>
-        <p:txBody>
-          <a:bodyPr wrap="square" lIns="0" rIns="0" tIns="0" bIns="0" anchor="ctr">
-            <a:spAutoFit/>
-          </a:bodyPr>
-          <a:lstStyle/>
-          <a:p>
-            <a:pPr algn="l"/>
-            <a:r>
-              <a:rPr sz="1200" b="0">
-                <a:solidFill>
-                  <a:srgbClr val="9A9AA2"/>
-                </a:solidFill>
-                <a:latin typeface="Poppins"/>
-              </a:rPr>
-              <a:t>All eight chain stages map onto the six classic phases.</a:t>
-            </a:r>
-          </a:p>
-        </p:txBody>
-      </p:sp>
       <p:pic>
         <p:nvPicPr>
-          <p:cNvPr id="62" name="Picture 61" descr="logo.png"/>
+          <p:cNvPr id="61" name="Picture 60" descr="logo.png"/>
           <p:cNvPicPr>
             <a:picLocks noChangeAspect="1"/>
           </p:cNvPicPr>

</xml_diff>

<commit_message>
Add benefits slide with headcount comparison
New slide 6 leads with the three USPs. A role comparison carries the first
two visually — business analyst, designer and developer as muted tags on
the left, one orange "One developer" tag on the right with the agent note
beneath — so the headcount claim is shown rather than only asserted. The
three benefits sit below as icon, headline and body.

Only the three roles named in the claim appear on the left, rather than an
invented team size, so the comparison states exactly what is claimed.

Slides after it are renumbered (moat 07, references 08, one question 09,
appendix 10); the deck is now 15 slides. Adds people, person and layers
icons, and a chip helper that sizes role tags from measured text width.

Co-Authored-By: Claude Opus 5 <noreply@anthropic.com>
Claude-Session: https://claude.ai/code/session_01NE7LjVDasJP9MMdSCEnLZ6
</commit_message>
<xml_diff>
--- a/deck/Pitch_Deck_AthenaRun_v2.pptx
+++ b/deck/Pitch_Deck_AthenaRun_v2.pptx
@@ -13,10 +13,11 @@
     <p:sldId id="258" r:id="rId10"/>
     <p:sldId id="265" r:id="rId17"/>
     <p:sldId id="266" r:id="rId18"/>
+    <p:sldId id="267" r:id="rId19"/>
     <p:sldId id="259" r:id="rId11"/>
-    <p:sldId id="267" r:id="rId19"/>
     <p:sldId id="268" r:id="rId20"/>
     <p:sldId id="269" r:id="rId21"/>
+    <p:sldId id="270" r:id="rId22"/>
     <p:sldId id="260" r:id="rId12"/>
     <p:sldId id="261" r:id="rId13"/>
     <p:sldId id="262" r:id="rId14"/>
@@ -6743,7 +6744,7 @@
                 </a:solidFill>
                 <a:latin typeface="Poppins"/>
               </a:rPr>
-              <a:t>References.</a:t>
+              <a:t>The payoff.</a:t>
             </a:r>
             <a:r>
               <a:rPr sz="2700" b="0">
@@ -6752,7 +6753,7 @@
                 </a:solidFill>
                 <a:latin typeface="Poppins"/>
               </a:rPr>
-              <a:t> Three builds, three problems.</a:t>
+              <a:t> Fewer people. A better starting point.</a:t>
             </a:r>
           </a:p>
         </p:txBody>
@@ -6787,7 +6788,7 @@
                 </a:solidFill>
                 <a:latin typeface="Courier New"/>
               </a:rPr>
-              <a:t>07 — References</a:t>
+              <a:t>06 — The payoff</a:t>
             </a:r>
           </a:p>
         </p:txBody>
@@ -6844,8 +6845,8 @@
         </p:nvSpPr>
         <p:spPr>
           <a:xfrm>
-            <a:off x="698500" y="1320800"/>
-            <a:ext cx="8890000" cy="190500"/>
+            <a:off x="698500" y="1244600"/>
+            <a:ext cx="9652000" cy="254000"/>
           </a:xfrm>
           <a:prstGeom prst="rect">
             <a:avLst/>
@@ -6866,20 +6867,493 @@
                 </a:solidFill>
                 <a:latin typeface="Poppins"/>
               </a:rPr>
-              <a:t>Shipped software, not pilots. Each one replaced a process that was running manually.</a:t>
-            </a:r>
-          </a:p>
-        </p:txBody>
-      </p:sp>
-      <p:sp>
-        <p:nvSpPr>
-          <p:cNvPr id="7" name="Rectangle 6"/>
+              <a:t>The chain does the work that used to need a team — every project starts on what the last one learned.</a:t>
+            </a:r>
+          </a:p>
+        </p:txBody>
+      </p:sp>
+      <p:sp>
+        <p:nvSpPr>
+          <p:cNvPr id="7" name="TextBox 6"/>
+          <p:cNvSpPr txBox="1"/>
+          <p:nvPr/>
+        </p:nvSpPr>
+        <p:spPr>
+          <a:xfrm>
+            <a:off x="698500" y="1879600"/>
+            <a:ext cx="4445000" cy="165100"/>
+          </a:xfrm>
+          <a:prstGeom prst="rect">
+            <a:avLst/>
+          </a:prstGeom>
+          <a:noFill/>
+        </p:spPr>
+        <p:txBody>
+          <a:bodyPr wrap="square" lIns="0" rIns="0" tIns="0" bIns="0" anchor="ctr">
+            <a:spAutoFit/>
+          </a:bodyPr>
+          <a:lstStyle/>
+          <a:p>
+            <a:pPr algn="l"/>
+            <a:r>
+              <a:rPr sz="1100" b="0" spc="250">
+                <a:solidFill>
+                  <a:srgbClr val="9A9AA2"/>
+                </a:solidFill>
+                <a:latin typeface="Courier New"/>
+              </a:rPr>
+              <a:t>A TYPICAL PROJECT TEAM</a:t>
+            </a:r>
+          </a:p>
+        </p:txBody>
+      </p:sp>
+      <p:sp>
+        <p:nvSpPr>
+          <p:cNvPr id="8" name="Rounded Rectangle 7"/>
           <p:cNvSpPr/>
           <p:nvPr/>
         </p:nvSpPr>
         <p:spPr>
           <a:xfrm>
-            <a:off x="698500" y="1828800"/>
+            <a:off x="698500" y="2197100"/>
+            <a:ext cx="2025650" cy="355600"/>
+          </a:xfrm>
+          <a:prstGeom prst="roundRect">
+            <a:avLst/>
+          </a:prstGeom>
+          <a:solidFill>
+            <a:srgbClr val="161619"/>
+          </a:solidFill>
+          <a:ln w="15875">
+            <a:solidFill>
+              <a:srgbClr val="9A9AA2"/>
+            </a:solidFill>
+          </a:ln>
+          <a:effectLst/>
+        </p:spPr>
+        <p:style>
+          <a:lnRef idx="1">
+            <a:schemeClr val="accent1"/>
+          </a:lnRef>
+          <a:fillRef idx="3">
+            <a:schemeClr val="accent1"/>
+          </a:fillRef>
+          <a:effectRef idx="2">
+            <a:schemeClr val="accent1"/>
+          </a:effectRef>
+          <a:fontRef idx="minor">
+            <a:schemeClr val="lt1"/>
+          </a:fontRef>
+        </p:style>
+        <p:txBody>
+          <a:bodyPr rtlCol="0" anchor="ctr"/>
+          <a:lstStyle/>
+          <a:p>
+            <a:pPr algn="ctr"/>
+          </a:p>
+        </p:txBody>
+      </p:sp>
+      <p:sp>
+        <p:nvSpPr>
+          <p:cNvPr id="9" name="TextBox 8"/>
+          <p:cNvSpPr txBox="1"/>
+          <p:nvPr/>
+        </p:nvSpPr>
+        <p:spPr>
+          <a:xfrm>
+            <a:off x="698500" y="2197100"/>
+            <a:ext cx="2025650" cy="355600"/>
+          </a:xfrm>
+          <a:prstGeom prst="rect">
+            <a:avLst/>
+          </a:prstGeom>
+          <a:noFill/>
+        </p:spPr>
+        <p:txBody>
+          <a:bodyPr wrap="square" lIns="0" rIns="0" tIns="0" bIns="0" anchor="ctr">
+            <a:spAutoFit/>
+          </a:bodyPr>
+          <a:lstStyle/>
+          <a:p>
+            <a:pPr algn="ctr"/>
+            <a:r>
+              <a:rPr sz="1400" b="0">
+                <a:solidFill>
+                  <a:srgbClr val="9A9AA2"/>
+                </a:solidFill>
+                <a:latin typeface="Poppins"/>
+              </a:rPr>
+              <a:t>Business Analyst</a:t>
+            </a:r>
+          </a:p>
+        </p:txBody>
+      </p:sp>
+      <p:sp>
+        <p:nvSpPr>
+          <p:cNvPr id="10" name="Rounded Rectangle 9"/>
+          <p:cNvSpPr/>
+          <p:nvPr/>
+        </p:nvSpPr>
+        <p:spPr>
+          <a:xfrm>
+            <a:off x="2851150" y="2197100"/>
+            <a:ext cx="1339850" cy="355600"/>
+          </a:xfrm>
+          <a:prstGeom prst="roundRect">
+            <a:avLst/>
+          </a:prstGeom>
+          <a:solidFill>
+            <a:srgbClr val="161619"/>
+          </a:solidFill>
+          <a:ln w="15875">
+            <a:solidFill>
+              <a:srgbClr val="9A9AA2"/>
+            </a:solidFill>
+          </a:ln>
+          <a:effectLst/>
+        </p:spPr>
+        <p:style>
+          <a:lnRef idx="1">
+            <a:schemeClr val="accent1"/>
+          </a:lnRef>
+          <a:fillRef idx="3">
+            <a:schemeClr val="accent1"/>
+          </a:fillRef>
+          <a:effectRef idx="2">
+            <a:schemeClr val="accent1"/>
+          </a:effectRef>
+          <a:fontRef idx="minor">
+            <a:schemeClr val="lt1"/>
+          </a:fontRef>
+        </p:style>
+        <p:txBody>
+          <a:bodyPr rtlCol="0" anchor="ctr"/>
+          <a:lstStyle/>
+          <a:p>
+            <a:pPr algn="ctr"/>
+          </a:p>
+        </p:txBody>
+      </p:sp>
+      <p:sp>
+        <p:nvSpPr>
+          <p:cNvPr id="11" name="TextBox 10"/>
+          <p:cNvSpPr txBox="1"/>
+          <p:nvPr/>
+        </p:nvSpPr>
+        <p:spPr>
+          <a:xfrm>
+            <a:off x="2851150" y="2197100"/>
+            <a:ext cx="1339850" cy="355600"/>
+          </a:xfrm>
+          <a:prstGeom prst="rect">
+            <a:avLst/>
+          </a:prstGeom>
+          <a:noFill/>
+        </p:spPr>
+        <p:txBody>
+          <a:bodyPr wrap="square" lIns="0" rIns="0" tIns="0" bIns="0" anchor="ctr">
+            <a:spAutoFit/>
+          </a:bodyPr>
+          <a:lstStyle/>
+          <a:p>
+            <a:pPr algn="ctr"/>
+            <a:r>
+              <a:rPr sz="1400" b="0">
+                <a:solidFill>
+                  <a:srgbClr val="9A9AA2"/>
+                </a:solidFill>
+                <a:latin typeface="Poppins"/>
+              </a:rPr>
+              <a:t>Designer</a:t>
+            </a:r>
+          </a:p>
+        </p:txBody>
+      </p:sp>
+      <p:sp>
+        <p:nvSpPr>
+          <p:cNvPr id="12" name="Rounded Rectangle 11"/>
+          <p:cNvSpPr/>
+          <p:nvPr/>
+        </p:nvSpPr>
+        <p:spPr>
+          <a:xfrm>
+            <a:off x="4324350" y="2197100"/>
+            <a:ext cx="1454150" cy="355600"/>
+          </a:xfrm>
+          <a:prstGeom prst="roundRect">
+            <a:avLst/>
+          </a:prstGeom>
+          <a:solidFill>
+            <a:srgbClr val="161619"/>
+          </a:solidFill>
+          <a:ln w="15875">
+            <a:solidFill>
+              <a:srgbClr val="9A9AA2"/>
+            </a:solidFill>
+          </a:ln>
+          <a:effectLst/>
+        </p:spPr>
+        <p:style>
+          <a:lnRef idx="1">
+            <a:schemeClr val="accent1"/>
+          </a:lnRef>
+          <a:fillRef idx="3">
+            <a:schemeClr val="accent1"/>
+          </a:fillRef>
+          <a:effectRef idx="2">
+            <a:schemeClr val="accent1"/>
+          </a:effectRef>
+          <a:fontRef idx="minor">
+            <a:schemeClr val="lt1"/>
+          </a:fontRef>
+        </p:style>
+        <p:txBody>
+          <a:bodyPr rtlCol="0" anchor="ctr"/>
+          <a:lstStyle/>
+          <a:p>
+            <a:pPr algn="ctr"/>
+          </a:p>
+        </p:txBody>
+      </p:sp>
+      <p:sp>
+        <p:nvSpPr>
+          <p:cNvPr id="13" name="TextBox 12"/>
+          <p:cNvSpPr txBox="1"/>
+          <p:nvPr/>
+        </p:nvSpPr>
+        <p:spPr>
+          <a:xfrm>
+            <a:off x="4324350" y="2197100"/>
+            <a:ext cx="1454150" cy="355600"/>
+          </a:xfrm>
+          <a:prstGeom prst="rect">
+            <a:avLst/>
+          </a:prstGeom>
+          <a:noFill/>
+        </p:spPr>
+        <p:txBody>
+          <a:bodyPr wrap="square" lIns="0" rIns="0" tIns="0" bIns="0" anchor="ctr">
+            <a:spAutoFit/>
+          </a:bodyPr>
+          <a:lstStyle/>
+          <a:p>
+            <a:pPr algn="ctr"/>
+            <a:r>
+              <a:rPr sz="1400" b="0">
+                <a:solidFill>
+                  <a:srgbClr val="9A9AA2"/>
+                </a:solidFill>
+                <a:latin typeface="Poppins"/>
+              </a:rPr>
+              <a:t>Developer</a:t>
+            </a:r>
+          </a:p>
+        </p:txBody>
+      </p:sp>
+      <p:sp>
+        <p:nvSpPr>
+          <p:cNvPr id="14" name="Isosceles Triangle 13"/>
+          <p:cNvSpPr/>
+          <p:nvPr/>
+        </p:nvSpPr>
+        <p:spPr>
+          <a:xfrm rot="5400000">
+            <a:off x="6026150" y="2292350"/>
+            <a:ext cx="165100" cy="165100"/>
+          </a:xfrm>
+          <a:prstGeom prst="triangle">
+            <a:avLst/>
+          </a:prstGeom>
+          <a:solidFill>
+            <a:srgbClr val="5A5A60"/>
+          </a:solidFill>
+          <a:ln>
+            <a:noFill/>
+          </a:ln>
+          <a:effectLst/>
+        </p:spPr>
+        <p:style>
+          <a:lnRef idx="1">
+            <a:schemeClr val="accent1"/>
+          </a:lnRef>
+          <a:fillRef idx="3">
+            <a:schemeClr val="accent1"/>
+          </a:fillRef>
+          <a:effectRef idx="2">
+            <a:schemeClr val="accent1"/>
+          </a:effectRef>
+          <a:fontRef idx="minor">
+            <a:schemeClr val="lt1"/>
+          </a:fontRef>
+        </p:style>
+        <p:txBody>
+          <a:bodyPr rtlCol="0" anchor="ctr"/>
+          <a:lstStyle/>
+          <a:p>
+            <a:pPr algn="ctr"/>
+          </a:p>
+        </p:txBody>
+      </p:sp>
+      <p:sp>
+        <p:nvSpPr>
+          <p:cNvPr id="15" name="TextBox 14"/>
+          <p:cNvSpPr txBox="1"/>
+          <p:nvPr/>
+        </p:nvSpPr>
+        <p:spPr>
+          <a:xfrm>
+            <a:off x="6604000" y="1879600"/>
+            <a:ext cx="4445000" cy="165100"/>
+          </a:xfrm>
+          <a:prstGeom prst="rect">
+            <a:avLst/>
+          </a:prstGeom>
+          <a:noFill/>
+        </p:spPr>
+        <p:txBody>
+          <a:bodyPr wrap="square" lIns="0" rIns="0" tIns="0" bIns="0" anchor="ctr">
+            <a:spAutoFit/>
+          </a:bodyPr>
+          <a:lstStyle/>
+          <a:p>
+            <a:pPr algn="l"/>
+            <a:r>
+              <a:rPr sz="1100" b="0" spc="250">
+                <a:solidFill>
+                  <a:srgbClr val="FF6B3D"/>
+                </a:solidFill>
+                <a:latin typeface="Courier New"/>
+              </a:rPr>
+              <a:t>WITH ATHENARUN</a:t>
+            </a:r>
+          </a:p>
+        </p:txBody>
+      </p:sp>
+      <p:sp>
+        <p:nvSpPr>
+          <p:cNvPr id="16" name="Rounded Rectangle 15"/>
+          <p:cNvSpPr/>
+          <p:nvPr/>
+        </p:nvSpPr>
+        <p:spPr>
+          <a:xfrm>
+            <a:off x="6604000" y="2197100"/>
+            <a:ext cx="1955800" cy="355600"/>
+          </a:xfrm>
+          <a:prstGeom prst="roundRect">
+            <a:avLst/>
+          </a:prstGeom>
+          <a:solidFill>
+            <a:srgbClr val="161619"/>
+          </a:solidFill>
+          <a:ln w="15875">
+            <a:solidFill>
+              <a:srgbClr val="FF6B3D"/>
+            </a:solidFill>
+          </a:ln>
+          <a:effectLst/>
+        </p:spPr>
+        <p:style>
+          <a:lnRef idx="1">
+            <a:schemeClr val="accent1"/>
+          </a:lnRef>
+          <a:fillRef idx="3">
+            <a:schemeClr val="accent1"/>
+          </a:fillRef>
+          <a:effectRef idx="2">
+            <a:schemeClr val="accent1"/>
+          </a:effectRef>
+          <a:fontRef idx="minor">
+            <a:schemeClr val="lt1"/>
+          </a:fontRef>
+        </p:style>
+        <p:txBody>
+          <a:bodyPr rtlCol="0" anchor="ctr"/>
+          <a:lstStyle/>
+          <a:p>
+            <a:pPr algn="ctr"/>
+          </a:p>
+        </p:txBody>
+      </p:sp>
+      <p:sp>
+        <p:nvSpPr>
+          <p:cNvPr id="17" name="TextBox 16"/>
+          <p:cNvSpPr txBox="1"/>
+          <p:nvPr/>
+        </p:nvSpPr>
+        <p:spPr>
+          <a:xfrm>
+            <a:off x="6604000" y="2197100"/>
+            <a:ext cx="1955800" cy="355600"/>
+          </a:xfrm>
+          <a:prstGeom prst="rect">
+            <a:avLst/>
+          </a:prstGeom>
+          <a:noFill/>
+        </p:spPr>
+        <p:txBody>
+          <a:bodyPr wrap="square" lIns="0" rIns="0" tIns="0" bIns="0" anchor="ctr">
+            <a:spAutoFit/>
+          </a:bodyPr>
+          <a:lstStyle/>
+          <a:p>
+            <a:pPr algn="ctr"/>
+            <a:r>
+              <a:rPr sz="1500" b="0">
+                <a:solidFill>
+                  <a:srgbClr val="FF6B3D"/>
+                </a:solidFill>
+                <a:latin typeface="Poppins"/>
+              </a:rPr>
+              <a:t>One developer</a:t>
+            </a:r>
+          </a:p>
+        </p:txBody>
+      </p:sp>
+      <p:sp>
+        <p:nvSpPr>
+          <p:cNvPr id="18" name="TextBox 17"/>
+          <p:cNvSpPr txBox="1"/>
+          <p:nvPr/>
+        </p:nvSpPr>
+        <p:spPr>
+          <a:xfrm>
+            <a:off x="6604000" y="2692400"/>
+            <a:ext cx="4445000" cy="165100"/>
+          </a:xfrm>
+          <a:prstGeom prst="rect">
+            <a:avLst/>
+          </a:prstGeom>
+          <a:noFill/>
+        </p:spPr>
+        <p:txBody>
+          <a:bodyPr wrap="square" lIns="0" rIns="0" tIns="0" bIns="0" anchor="ctr">
+            <a:spAutoFit/>
+          </a:bodyPr>
+          <a:lstStyle/>
+          <a:p>
+            <a:pPr algn="l"/>
+            <a:r>
+              <a:rPr sz="1250" b="0">
+                <a:solidFill>
+                  <a:srgbClr val="9A9AA2"/>
+                </a:solidFill>
+                <a:latin typeface="Poppins"/>
+              </a:rPr>
+              <a:t>+ agents on all six lifecycle phases</a:t>
+            </a:r>
+          </a:p>
+        </p:txBody>
+      </p:sp>
+      <p:sp>
+        <p:nvSpPr>
+          <p:cNvPr id="19" name="Rectangle 18"/>
+          <p:cNvSpPr/>
+          <p:nvPr/>
+        </p:nvSpPr>
+        <p:spPr>
+          <a:xfrm>
+            <a:off x="698500" y="3302000"/>
             <a:ext cx="10788650" cy="6350"/>
           </a:xfrm>
           <a:prstGeom prst="rect">
@@ -6915,53 +7389,9 @@
           </a:p>
         </p:txBody>
       </p:sp>
-      <p:sp>
-        <p:nvSpPr>
-          <p:cNvPr id="8" name="Rectangle 7"/>
-          <p:cNvSpPr/>
-          <p:nvPr/>
-        </p:nvSpPr>
-        <p:spPr>
-          <a:xfrm>
-            <a:off x="698500" y="2159000"/>
-            <a:ext cx="3302000" cy="2857500"/>
-          </a:xfrm>
-          <a:prstGeom prst="rect">
-            <a:avLst/>
-          </a:prstGeom>
-          <a:solidFill>
-            <a:srgbClr val="161619"/>
-          </a:solidFill>
-          <a:ln>
-            <a:noFill/>
-          </a:ln>
-          <a:effectLst/>
-        </p:spPr>
-        <p:style>
-          <a:lnRef idx="1">
-            <a:schemeClr val="accent1"/>
-          </a:lnRef>
-          <a:fillRef idx="3">
-            <a:schemeClr val="accent1"/>
-          </a:fillRef>
-          <a:effectRef idx="2">
-            <a:schemeClr val="accent1"/>
-          </a:effectRef>
-          <a:fontRef idx="minor">
-            <a:schemeClr val="lt1"/>
-          </a:fontRef>
-        </p:style>
-        <p:txBody>
-          <a:bodyPr rtlCol="0" anchor="ctr"/>
-          <a:lstStyle/>
-          <a:p>
-            <a:pPr algn="ctr"/>
-          </a:p>
-        </p:txBody>
-      </p:sp>
       <p:pic>
         <p:nvPicPr>
-          <p:cNvPr id="9" name="Picture 8" descr="ic-chart.png"/>
+          <p:cNvPr id="20" name="Picture 19" descr="ic-people.png"/>
           <p:cNvPicPr>
             <a:picLocks noChangeAspect="1"/>
           </p:cNvPicPr>
@@ -6975,8 +7405,8 @@
         </p:blipFill>
         <p:spPr>
           <a:xfrm>
-            <a:off x="952500" y="2400300"/>
-            <a:ext cx="215900" cy="215900"/>
+            <a:off x="698500" y="3594100"/>
+            <a:ext cx="279400" cy="279400"/>
           </a:xfrm>
           <a:prstGeom prst="rect">
             <a:avLst/>
@@ -6985,14 +7415,14 @@
       </p:pic>
       <p:sp>
         <p:nvSpPr>
-          <p:cNvPr id="10" name="TextBox 9"/>
-          <p:cNvSpPr txBox="1"/>
-          <p:nvPr/>
-        </p:nvSpPr>
-        <p:spPr>
-          <a:xfrm>
-            <a:off x="952500" y="2717800"/>
-            <a:ext cx="2794000" cy="279400"/>
+          <p:cNvPr id="21" name="TextBox 20"/>
+          <p:cNvSpPr txBox="1"/>
+          <p:nvPr/>
+        </p:nvSpPr>
+        <p:spPr>
+          <a:xfrm>
+            <a:off x="698500" y="4013200"/>
+            <a:ext cx="3302000" cy="228600"/>
           </a:xfrm>
           <a:prstGeom prst="rect">
             <a:avLst/>
@@ -7007,27 +7437,27 @@
           <a:p>
             <a:pPr algn="l"/>
             <a:r>
-              <a:rPr sz="2000" b="0">
+              <a:rPr sz="1800" b="0">
                 <a:solidFill>
                   <a:srgbClr val="ECECEE"/>
                 </a:solidFill>
                 <a:latin typeface="Poppins"/>
               </a:rPr>
-              <a:t>CFO App</a:t>
-            </a:r>
-          </a:p>
-        </p:txBody>
-      </p:sp>
-      <p:sp>
-        <p:nvSpPr>
-          <p:cNvPr id="11" name="TextBox 10"/>
-          <p:cNvSpPr txBox="1"/>
-          <p:nvPr/>
-        </p:nvSpPr>
-        <p:spPr>
-          <a:xfrm>
-            <a:off x="952500" y="3175000"/>
-            <a:ext cx="2794000" cy="127000"/>
+              <a:t>Fewer roles per project</a:t>
+            </a:r>
+          </a:p>
+        </p:txBody>
+      </p:sp>
+      <p:sp>
+        <p:nvSpPr>
+          <p:cNvPr id="22" name="TextBox 21"/>
+          <p:cNvSpPr txBox="1"/>
+          <p:nvPr/>
+        </p:nvSpPr>
+        <p:spPr>
+          <a:xfrm>
+            <a:off x="698500" y="4394200"/>
+            <a:ext cx="3302000" cy="736600"/>
           </a:xfrm>
           <a:prstGeom prst="rect">
             <a:avLst/>
@@ -7040,253 +7470,26 @@
           </a:bodyPr>
           <a:lstStyle/>
           <a:p>
-            <a:pPr algn="l"/>
-            <a:r>
-              <a:rPr sz="900" b="0" spc="200">
-                <a:solidFill>
-                  <a:srgbClr val="9A9AA2"/>
-                </a:solidFill>
-                <a:latin typeface="Courier New"/>
-              </a:rPr>
-              <a:t>CLIENT / SECTOR</a:t>
-            </a:r>
-          </a:p>
-        </p:txBody>
-      </p:sp>
-      <p:sp>
-        <p:nvSpPr>
-          <p:cNvPr id="12" name="TextBox 11"/>
-          <p:cNvSpPr txBox="1"/>
-          <p:nvPr/>
-        </p:nvSpPr>
-        <p:spPr>
-          <a:xfrm>
-            <a:off x="952500" y="3340100"/>
-            <a:ext cx="2794000" cy="342900"/>
-          </a:xfrm>
-          <a:prstGeom prst="rect">
-            <a:avLst/>
-          </a:prstGeom>
-          <a:noFill/>
-        </p:spPr>
-        <p:txBody>
-          <a:bodyPr wrap="square" lIns="0" rIns="0" tIns="0" bIns="0" anchor="ctr">
-            <a:spAutoFit/>
-          </a:bodyPr>
-          <a:lstStyle/>
-          <a:p>
             <a:pPr algn="l">
               <a:lnSpc>
-                <a:spcPts val="1600"/>
+                <a:spcPts val="1900"/>
               </a:lnSpc>
             </a:pPr>
             <a:r>
               <a:rPr sz="1300" b="0">
                 <a:solidFill>
-                  <a:srgbClr val="FF6B3D"/>
+                  <a:srgbClr val="9A9AA2"/>
                 </a:solidFill>
                 <a:latin typeface="Poppins"/>
               </a:rPr>
-              <a:t>[Kunde oder Branche]</a:t>
-            </a:r>
-          </a:p>
-        </p:txBody>
-      </p:sp>
-      <p:sp>
-        <p:nvSpPr>
-          <p:cNvPr id="13" name="TextBox 12"/>
-          <p:cNvSpPr txBox="1"/>
-          <p:nvPr/>
-        </p:nvSpPr>
-        <p:spPr>
-          <a:xfrm>
-            <a:off x="952500" y="3759200"/>
-            <a:ext cx="2794000" cy="127000"/>
-          </a:xfrm>
-          <a:prstGeom prst="rect">
-            <a:avLst/>
-          </a:prstGeom>
-          <a:noFill/>
-        </p:spPr>
-        <p:txBody>
-          <a:bodyPr wrap="square" lIns="0" rIns="0" tIns="0" bIns="0" anchor="ctr">
-            <a:spAutoFit/>
-          </a:bodyPr>
-          <a:lstStyle/>
-          <a:p>
-            <a:pPr algn="l"/>
-            <a:r>
-              <a:rPr sz="900" b="0" spc="200">
-                <a:solidFill>
-                  <a:srgbClr val="9A9AA2"/>
-                </a:solidFill>
-                <a:latin typeface="Courier New"/>
-              </a:rPr>
-              <a:t>WHAT WE BUILT</a:t>
-            </a:r>
-          </a:p>
-        </p:txBody>
-      </p:sp>
-      <p:sp>
-        <p:nvSpPr>
-          <p:cNvPr id="14" name="TextBox 13"/>
-          <p:cNvSpPr txBox="1"/>
-          <p:nvPr/>
-        </p:nvSpPr>
-        <p:spPr>
-          <a:xfrm>
-            <a:off x="952500" y="3924300"/>
-            <a:ext cx="2794000" cy="342900"/>
-          </a:xfrm>
-          <a:prstGeom prst="rect">
-            <a:avLst/>
-          </a:prstGeom>
-          <a:noFill/>
-        </p:spPr>
-        <p:txBody>
-          <a:bodyPr wrap="square" lIns="0" rIns="0" tIns="0" bIns="0" anchor="ctr">
-            <a:spAutoFit/>
-          </a:bodyPr>
-          <a:lstStyle/>
-          <a:p>
-            <a:pPr algn="l">
-              <a:lnSpc>
-                <a:spcPts val="1600"/>
-              </a:lnSpc>
-            </a:pPr>
-            <a:r>
-              <a:rPr sz="1300" b="0">
-                <a:solidFill>
-                  <a:srgbClr val="FF6B3D"/>
-                </a:solidFill>
-                <a:latin typeface="Poppins"/>
-              </a:rPr>
-              <a:t>[was gebaut wurde]</a:t>
-            </a:r>
-          </a:p>
-        </p:txBody>
-      </p:sp>
-      <p:sp>
-        <p:nvSpPr>
-          <p:cNvPr id="15" name="TextBox 14"/>
-          <p:cNvSpPr txBox="1"/>
-          <p:nvPr/>
-        </p:nvSpPr>
-        <p:spPr>
-          <a:xfrm>
-            <a:off x="952500" y="4343400"/>
-            <a:ext cx="2794000" cy="127000"/>
-          </a:xfrm>
-          <a:prstGeom prst="rect">
-            <a:avLst/>
-          </a:prstGeom>
-          <a:noFill/>
-        </p:spPr>
-        <p:txBody>
-          <a:bodyPr wrap="square" lIns="0" rIns="0" tIns="0" bIns="0" anchor="ctr">
-            <a:spAutoFit/>
-          </a:bodyPr>
-          <a:lstStyle/>
-          <a:p>
-            <a:pPr algn="l"/>
-            <a:r>
-              <a:rPr sz="900" b="0" spc="200">
-                <a:solidFill>
-                  <a:srgbClr val="9A9AA2"/>
-                </a:solidFill>
-                <a:latin typeface="Courier New"/>
-              </a:rPr>
-              <a:t>RESULT</a:t>
-            </a:r>
-          </a:p>
-        </p:txBody>
-      </p:sp>
-      <p:sp>
-        <p:nvSpPr>
-          <p:cNvPr id="16" name="TextBox 15"/>
-          <p:cNvSpPr txBox="1"/>
-          <p:nvPr/>
-        </p:nvSpPr>
-        <p:spPr>
-          <a:xfrm>
-            <a:off x="952500" y="4508500"/>
-            <a:ext cx="2794000" cy="342900"/>
-          </a:xfrm>
-          <a:prstGeom prst="rect">
-            <a:avLst/>
-          </a:prstGeom>
-          <a:noFill/>
-        </p:spPr>
-        <p:txBody>
-          <a:bodyPr wrap="square" lIns="0" rIns="0" tIns="0" bIns="0" anchor="ctr">
-            <a:spAutoFit/>
-          </a:bodyPr>
-          <a:lstStyle/>
-          <a:p>
-            <a:pPr algn="l">
-              <a:lnSpc>
-                <a:spcPts val="1600"/>
-              </a:lnSpc>
-            </a:pPr>
-            <a:r>
-              <a:rPr sz="1300" b="0">
-                <a:solidFill>
-                  <a:srgbClr val="FF6B3D"/>
-                </a:solidFill>
-                <a:latin typeface="Poppins"/>
-              </a:rPr>
-              <a:t>[Ergebnis in einer Zeile]</a:t>
-            </a:r>
-          </a:p>
-        </p:txBody>
-      </p:sp>
-      <p:sp>
-        <p:nvSpPr>
-          <p:cNvPr id="17" name="Rectangle 16"/>
-          <p:cNvSpPr/>
-          <p:nvPr/>
-        </p:nvSpPr>
-        <p:spPr>
-          <a:xfrm>
-            <a:off x="4318000" y="2159000"/>
-            <a:ext cx="3302000" cy="2857500"/>
-          </a:xfrm>
-          <a:prstGeom prst="rect">
-            <a:avLst/>
-          </a:prstGeom>
-          <a:solidFill>
-            <a:srgbClr val="161619"/>
-          </a:solidFill>
-          <a:ln>
-            <a:noFill/>
-          </a:ln>
-          <a:effectLst/>
-        </p:spPr>
-        <p:style>
-          <a:lnRef idx="1">
-            <a:schemeClr val="accent1"/>
-          </a:lnRef>
-          <a:fillRef idx="3">
-            <a:schemeClr val="accent1"/>
-          </a:fillRef>
-          <a:effectRef idx="2">
-            <a:schemeClr val="accent1"/>
-          </a:effectRef>
-          <a:fontRef idx="minor">
-            <a:schemeClr val="lt1"/>
-          </a:fontRef>
-        </p:style>
-        <p:txBody>
-          <a:bodyPr rtlCol="0" anchor="ctr"/>
-          <a:lstStyle/>
-          <a:p>
-            <a:pPr algn="ctr"/>
+              <a:t>Eliminates or reduces business analyst, designer and developer headcount on every project.</a:t>
+            </a:r>
           </a:p>
         </p:txBody>
       </p:sp>
       <p:pic>
         <p:nvPicPr>
-          <p:cNvPr id="18" name="Picture 17" descr="ic-funnel.png"/>
+          <p:cNvPr id="23" name="Picture 22" descr="ic-person.png"/>
           <p:cNvPicPr>
             <a:picLocks noChangeAspect="1"/>
           </p:cNvPicPr>
@@ -7300,8 +7503,8 @@
         </p:blipFill>
         <p:spPr>
           <a:xfrm>
-            <a:off x="4572000" y="2400300"/>
-            <a:ext cx="215900" cy="215900"/>
+            <a:off x="4318000" y="3594100"/>
+            <a:ext cx="279400" cy="279400"/>
           </a:xfrm>
           <a:prstGeom prst="rect">
             <a:avLst/>
@@ -7310,14 +7513,14 @@
       </p:pic>
       <p:sp>
         <p:nvSpPr>
-          <p:cNvPr id="19" name="TextBox 18"/>
-          <p:cNvSpPr txBox="1"/>
-          <p:nvPr/>
-        </p:nvSpPr>
-        <p:spPr>
-          <a:xfrm>
-            <a:off x="4572000" y="2717800"/>
-            <a:ext cx="2794000" cy="279400"/>
+          <p:cNvPr id="24" name="TextBox 23"/>
+          <p:cNvSpPr txBox="1"/>
+          <p:nvPr/>
+        </p:nvSpPr>
+        <p:spPr>
+          <a:xfrm>
+            <a:off x="4318000" y="4013200"/>
+            <a:ext cx="3302000" cy="228600"/>
           </a:xfrm>
           <a:prstGeom prst="rect">
             <a:avLst/>
@@ -7332,27 +7535,27 @@
           <a:p>
             <a:pPr algn="l"/>
             <a:r>
-              <a:rPr sz="2000" b="0">
+              <a:rPr sz="1800" b="0">
                 <a:solidFill>
                   <a:srgbClr val="ECECEE"/>
                 </a:solidFill>
                 <a:latin typeface="Poppins"/>
               </a:rPr>
-              <a:t>Lead Generation</a:t>
-            </a:r>
-          </a:p>
-        </p:txBody>
-      </p:sp>
-      <p:sp>
-        <p:nvSpPr>
-          <p:cNvPr id="20" name="TextBox 19"/>
-          <p:cNvSpPr txBox="1"/>
-          <p:nvPr/>
-        </p:nvSpPr>
-        <p:spPr>
-          <a:xfrm>
-            <a:off x="4572000" y="3175000"/>
-            <a:ext cx="2794000" cy="127000"/>
+              <a:t>One developer, internally</a:t>
+            </a:r>
+          </a:p>
+        </p:txBody>
+      </p:sp>
+      <p:sp>
+        <p:nvSpPr>
+          <p:cNvPr id="25" name="TextBox 24"/>
+          <p:cNvSpPr txBox="1"/>
+          <p:nvPr/>
+        </p:nvSpPr>
+        <p:spPr>
+          <a:xfrm>
+            <a:off x="4318000" y="4394200"/>
+            <a:ext cx="3302000" cy="736600"/>
           </a:xfrm>
           <a:prstGeom prst="rect">
             <a:avLst/>
@@ -7365,253 +7568,26 @@
           </a:bodyPr>
           <a:lstStyle/>
           <a:p>
-            <a:pPr algn="l"/>
-            <a:r>
-              <a:rPr sz="900" b="0" spc="200">
-                <a:solidFill>
-                  <a:srgbClr val="9A9AA2"/>
-                </a:solidFill>
-                <a:latin typeface="Courier New"/>
-              </a:rPr>
-              <a:t>CLIENT / SECTOR</a:t>
-            </a:r>
-          </a:p>
-        </p:txBody>
-      </p:sp>
-      <p:sp>
-        <p:nvSpPr>
-          <p:cNvPr id="21" name="TextBox 20"/>
-          <p:cNvSpPr txBox="1"/>
-          <p:nvPr/>
-        </p:nvSpPr>
-        <p:spPr>
-          <a:xfrm>
-            <a:off x="4572000" y="3340100"/>
-            <a:ext cx="2794000" cy="342900"/>
-          </a:xfrm>
-          <a:prstGeom prst="rect">
-            <a:avLst/>
-          </a:prstGeom>
-          <a:noFill/>
-        </p:spPr>
-        <p:txBody>
-          <a:bodyPr wrap="square" lIns="0" rIns="0" tIns="0" bIns="0" anchor="ctr">
-            <a:spAutoFit/>
-          </a:bodyPr>
-          <a:lstStyle/>
-          <a:p>
             <a:pPr algn="l">
               <a:lnSpc>
-                <a:spcPts val="1600"/>
+                <a:spcPts val="1900"/>
               </a:lnSpc>
             </a:pPr>
             <a:r>
               <a:rPr sz="1300" b="0">
                 <a:solidFill>
-                  <a:srgbClr val="FF6B3D"/>
+                  <a:srgbClr val="9A9AA2"/>
                 </a:solidFill>
                 <a:latin typeface="Poppins"/>
               </a:rPr>
-              <a:t>[Kunde oder Branche]</a:t>
-            </a:r>
-          </a:p>
-        </p:txBody>
-      </p:sp>
-      <p:sp>
-        <p:nvSpPr>
-          <p:cNvPr id="22" name="TextBox 21"/>
-          <p:cNvSpPr txBox="1"/>
-          <p:nvPr/>
-        </p:nvSpPr>
-        <p:spPr>
-          <a:xfrm>
-            <a:off x="4572000" y="3759200"/>
-            <a:ext cx="2794000" cy="127000"/>
-          </a:xfrm>
-          <a:prstGeom prst="rect">
-            <a:avLst/>
-          </a:prstGeom>
-          <a:noFill/>
-        </p:spPr>
-        <p:txBody>
-          <a:bodyPr wrap="square" lIns="0" rIns="0" tIns="0" bIns="0" anchor="ctr">
-            <a:spAutoFit/>
-          </a:bodyPr>
-          <a:lstStyle/>
-          <a:p>
-            <a:pPr algn="l"/>
-            <a:r>
-              <a:rPr sz="900" b="0" spc="200">
-                <a:solidFill>
-                  <a:srgbClr val="9A9AA2"/>
-                </a:solidFill>
-                <a:latin typeface="Courier New"/>
-              </a:rPr>
-              <a:t>WHAT WE BUILT</a:t>
-            </a:r>
-          </a:p>
-        </p:txBody>
-      </p:sp>
-      <p:sp>
-        <p:nvSpPr>
-          <p:cNvPr id="23" name="TextBox 22"/>
-          <p:cNvSpPr txBox="1"/>
-          <p:nvPr/>
-        </p:nvSpPr>
-        <p:spPr>
-          <a:xfrm>
-            <a:off x="4572000" y="3924300"/>
-            <a:ext cx="2794000" cy="342900"/>
-          </a:xfrm>
-          <a:prstGeom prst="rect">
-            <a:avLst/>
-          </a:prstGeom>
-          <a:noFill/>
-        </p:spPr>
-        <p:txBody>
-          <a:bodyPr wrap="square" lIns="0" rIns="0" tIns="0" bIns="0" anchor="ctr">
-            <a:spAutoFit/>
-          </a:bodyPr>
-          <a:lstStyle/>
-          <a:p>
-            <a:pPr algn="l">
-              <a:lnSpc>
-                <a:spcPts val="1600"/>
-              </a:lnSpc>
-            </a:pPr>
-            <a:r>
-              <a:rPr sz="1300" b="0">
-                <a:solidFill>
-                  <a:srgbClr val="FF6B3D"/>
-                </a:solidFill>
-                <a:latin typeface="Poppins"/>
-              </a:rPr>
-              <a:t>[was gebaut wurde]</a:t>
-            </a:r>
-          </a:p>
-        </p:txBody>
-      </p:sp>
-      <p:sp>
-        <p:nvSpPr>
-          <p:cNvPr id="24" name="TextBox 23"/>
-          <p:cNvSpPr txBox="1"/>
-          <p:nvPr/>
-        </p:nvSpPr>
-        <p:spPr>
-          <a:xfrm>
-            <a:off x="4572000" y="4343400"/>
-            <a:ext cx="2794000" cy="127000"/>
-          </a:xfrm>
-          <a:prstGeom prst="rect">
-            <a:avLst/>
-          </a:prstGeom>
-          <a:noFill/>
-        </p:spPr>
-        <p:txBody>
-          <a:bodyPr wrap="square" lIns="0" rIns="0" tIns="0" bIns="0" anchor="ctr">
-            <a:spAutoFit/>
-          </a:bodyPr>
-          <a:lstStyle/>
-          <a:p>
-            <a:pPr algn="l"/>
-            <a:r>
-              <a:rPr sz="900" b="0" spc="200">
-                <a:solidFill>
-                  <a:srgbClr val="9A9AA2"/>
-                </a:solidFill>
-                <a:latin typeface="Courier New"/>
-              </a:rPr>
-              <a:t>RESULT</a:t>
-            </a:r>
-          </a:p>
-        </p:txBody>
-      </p:sp>
-      <p:sp>
-        <p:nvSpPr>
-          <p:cNvPr id="25" name="TextBox 24"/>
-          <p:cNvSpPr txBox="1"/>
-          <p:nvPr/>
-        </p:nvSpPr>
-        <p:spPr>
-          <a:xfrm>
-            <a:off x="4572000" y="4508500"/>
-            <a:ext cx="2794000" cy="342900"/>
-          </a:xfrm>
-          <a:prstGeom prst="rect">
-            <a:avLst/>
-          </a:prstGeom>
-          <a:noFill/>
-        </p:spPr>
-        <p:txBody>
-          <a:bodyPr wrap="square" lIns="0" rIns="0" tIns="0" bIns="0" anchor="ctr">
-            <a:spAutoFit/>
-          </a:bodyPr>
-          <a:lstStyle/>
-          <a:p>
-            <a:pPr algn="l">
-              <a:lnSpc>
-                <a:spcPts val="1600"/>
-              </a:lnSpc>
-            </a:pPr>
-            <a:r>
-              <a:rPr sz="1300" b="0">
-                <a:solidFill>
-                  <a:srgbClr val="FF6B3D"/>
-                </a:solidFill>
-                <a:latin typeface="Poppins"/>
-              </a:rPr>
-              <a:t>[Ergebnis in einer Zeile]</a:t>
-            </a:r>
-          </a:p>
-        </p:txBody>
-      </p:sp>
-      <p:sp>
-        <p:nvSpPr>
-          <p:cNvPr id="26" name="Rectangle 25"/>
-          <p:cNvSpPr/>
-          <p:nvPr/>
-        </p:nvSpPr>
-        <p:spPr>
-          <a:xfrm>
-            <a:off x="7937500" y="2159000"/>
-            <a:ext cx="3302000" cy="2857500"/>
-          </a:xfrm>
-          <a:prstGeom prst="rect">
-            <a:avLst/>
-          </a:prstGeom>
-          <a:solidFill>
-            <a:srgbClr val="161619"/>
-          </a:solidFill>
-          <a:ln>
-            <a:noFill/>
-          </a:ln>
-          <a:effectLst/>
-        </p:spPr>
-        <p:style>
-          <a:lnRef idx="1">
-            <a:schemeClr val="accent1"/>
-          </a:lnRef>
-          <a:fillRef idx="3">
-            <a:schemeClr val="accent1"/>
-          </a:fillRef>
-          <a:effectRef idx="2">
-            <a:schemeClr val="accent1"/>
-          </a:effectRef>
-          <a:fontRef idx="minor">
-            <a:schemeClr val="lt1"/>
-          </a:fontRef>
-        </p:style>
-        <p:txBody>
-          <a:bodyPr rtlCol="0" anchor="ctr"/>
-          <a:lstStyle/>
-          <a:p>
-            <a:pPr algn="ctr"/>
+              <a:t>AthenaRun runs its own projects with a single developer.</a:t>
+            </a:r>
           </a:p>
         </p:txBody>
       </p:sp>
       <p:pic>
         <p:nvPicPr>
-          <p:cNvPr id="27" name="Picture 26" descr="ic-bubble.png"/>
+          <p:cNvPr id="26" name="Picture 25" descr="ic-layers.png"/>
           <p:cNvPicPr>
             <a:picLocks noChangeAspect="1"/>
           </p:cNvPicPr>
@@ -7625,8 +7601,8 @@
         </p:blipFill>
         <p:spPr>
           <a:xfrm>
-            <a:off x="8191500" y="2400300"/>
-            <a:ext cx="215900" cy="215900"/>
+            <a:off x="7937500" y="3594100"/>
+            <a:ext cx="279400" cy="279400"/>
           </a:xfrm>
           <a:prstGeom prst="rect">
             <a:avLst/>
@@ -7635,14 +7611,14 @@
       </p:pic>
       <p:sp>
         <p:nvSpPr>
-          <p:cNvPr id="28" name="TextBox 27"/>
-          <p:cNvSpPr txBox="1"/>
-          <p:nvPr/>
-        </p:nvSpPr>
-        <p:spPr>
-          <a:xfrm>
-            <a:off x="8191500" y="2717800"/>
-            <a:ext cx="2794000" cy="279400"/>
+          <p:cNvPr id="27" name="TextBox 26"/>
+          <p:cNvSpPr txBox="1"/>
+          <p:nvPr/>
+        </p:nvSpPr>
+        <p:spPr>
+          <a:xfrm>
+            <a:off x="7937500" y="4013200"/>
+            <a:ext cx="3302000" cy="228600"/>
           </a:xfrm>
           <a:prstGeom prst="rect">
             <a:avLst/>
@@ -7657,27 +7633,27 @@
           <a:p>
             <a:pPr algn="l"/>
             <a:r>
-              <a:rPr sz="2000" b="0">
+              <a:rPr sz="1800" b="0">
                 <a:solidFill>
                   <a:srgbClr val="ECECEE"/>
                 </a:solidFill>
                 <a:latin typeface="Poppins"/>
               </a:rPr>
-              <a:t>Board Assistant</a:t>
-            </a:r>
-          </a:p>
-        </p:txBody>
-      </p:sp>
-      <p:sp>
-        <p:nvSpPr>
-          <p:cNvPr id="29" name="TextBox 28"/>
-          <p:cNvSpPr txBox="1"/>
-          <p:nvPr/>
-        </p:nvSpPr>
-        <p:spPr>
-          <a:xfrm>
-            <a:off x="8191500" y="3175000"/>
-            <a:ext cx="2794000" cy="127000"/>
+              <a:t>A head start on day one</a:t>
+            </a:r>
+          </a:p>
+        </p:txBody>
+      </p:sp>
+      <p:sp>
+        <p:nvSpPr>
+          <p:cNvPr id="28" name="TextBox 27"/>
+          <p:cNvSpPr txBox="1"/>
+          <p:nvPr/>
+        </p:nvSpPr>
+        <p:spPr>
+          <a:xfrm>
+            <a:off x="7937500" y="4394200"/>
+            <a:ext cx="3302000" cy="736600"/>
           </a:xfrm>
           <a:prstGeom prst="rect">
             <a:avLst/>
@@ -7690,16 +7666,64 @@
           </a:bodyPr>
           <a:lstStyle/>
           <a:p>
-            <a:pPr algn="l"/>
-            <a:r>
-              <a:rPr sz="900" b="0" spc="200">
+            <a:pPr algn="l">
+              <a:lnSpc>
+                <a:spcPts val="1900"/>
+              </a:lnSpc>
+            </a:pPr>
+            <a:r>
+              <a:rPr sz="1300" b="0">
                 <a:solidFill>
                   <a:srgbClr val="9A9AA2"/>
                 </a:solidFill>
-                <a:latin typeface="Courier New"/>
-              </a:rPr>
-              <a:t>CLIENT / SECTOR</a:t>
-            </a:r>
+                <a:latin typeface="Poppins"/>
+              </a:rPr>
+              <a:t>Customers inherit validated best practices and documented failure learnings from the first build.</a:t>
+            </a:r>
+          </a:p>
+        </p:txBody>
+      </p:sp>
+      <p:sp>
+        <p:nvSpPr>
+          <p:cNvPr id="29" name="Rectangle 28"/>
+          <p:cNvSpPr/>
+          <p:nvPr/>
+        </p:nvSpPr>
+        <p:spPr>
+          <a:xfrm>
+            <a:off x="698500" y="5207000"/>
+            <a:ext cx="10788650" cy="6350"/>
+          </a:xfrm>
+          <a:prstGeom prst="rect">
+            <a:avLst/>
+          </a:prstGeom>
+          <a:solidFill>
+            <a:srgbClr val="2B2B2D"/>
+          </a:solidFill>
+          <a:ln>
+            <a:noFill/>
+          </a:ln>
+          <a:effectLst/>
+        </p:spPr>
+        <p:style>
+          <a:lnRef idx="1">
+            <a:schemeClr val="accent1"/>
+          </a:lnRef>
+          <a:fillRef idx="3">
+            <a:schemeClr val="accent1"/>
+          </a:fillRef>
+          <a:effectRef idx="2">
+            <a:schemeClr val="accent1"/>
+          </a:effectRef>
+          <a:fontRef idx="minor">
+            <a:schemeClr val="lt1"/>
+          </a:fontRef>
+        </p:style>
+        <p:txBody>
+          <a:bodyPr rtlCol="0" anchor="ctr"/>
+          <a:lstStyle/>
+          <a:p>
+            <a:pPr algn="ctr"/>
           </a:p>
         </p:txBody>
       </p:sp>
@@ -7711,8 +7735,8 @@
         </p:nvSpPr>
         <p:spPr>
           <a:xfrm>
-            <a:off x="8191500" y="3340100"/>
-            <a:ext cx="2794000" cy="342900"/>
+            <a:off x="698500" y="5410200"/>
+            <a:ext cx="9906000" cy="215900"/>
           </a:xfrm>
           <a:prstGeom prst="rect">
             <a:avLst/>
@@ -7725,209 +7749,31 @@
           </a:bodyPr>
           <a:lstStyle/>
           <a:p>
-            <a:pPr algn="l">
-              <a:lnSpc>
-                <a:spcPts val="1600"/>
-              </a:lnSpc>
-            </a:pPr>
-            <a:r>
-              <a:rPr sz="1300" b="0">
-                <a:solidFill>
-                  <a:srgbClr val="FF6B3D"/>
+            <a:pPr algn="l"/>
+            <a:r>
+              <a:rPr sz="1600" b="1">
+                <a:solidFill>
+                  <a:srgbClr val="ECECEE"/>
                 </a:solidFill>
                 <a:latin typeface="Poppins"/>
               </a:rPr>
-              <a:t>[Kunde oder Branche]</a:t>
-            </a:r>
-          </a:p>
-        </p:txBody>
-      </p:sp>
-      <p:sp>
-        <p:nvSpPr>
-          <p:cNvPr id="31" name="TextBox 30"/>
-          <p:cNvSpPr txBox="1"/>
-          <p:nvPr/>
-        </p:nvSpPr>
-        <p:spPr>
-          <a:xfrm>
-            <a:off x="8191500" y="3759200"/>
-            <a:ext cx="2794000" cy="127000"/>
-          </a:xfrm>
-          <a:prstGeom prst="rect">
-            <a:avLst/>
-          </a:prstGeom>
-          <a:noFill/>
-        </p:spPr>
-        <p:txBody>
-          <a:bodyPr wrap="square" lIns="0" rIns="0" tIns="0" bIns="0" anchor="ctr">
-            <a:spAutoFit/>
-          </a:bodyPr>
-          <a:lstStyle/>
-          <a:p>
-            <a:pPr algn="l"/>
-            <a:r>
-              <a:rPr sz="900" b="0" spc="200">
+              <a:t>Same scope, a fraction of the team.</a:t>
+            </a:r>
+            <a:r>
+              <a:rPr sz="1600" b="0">
                 <a:solidFill>
                   <a:srgbClr val="9A9AA2"/>
                 </a:solidFill>
-                <a:latin typeface="Courier New"/>
-              </a:rPr>
-              <a:t>WHAT WE BUILT</a:t>
-            </a:r>
-          </a:p>
-        </p:txBody>
-      </p:sp>
-      <p:sp>
-        <p:nvSpPr>
-          <p:cNvPr id="32" name="TextBox 31"/>
-          <p:cNvSpPr txBox="1"/>
-          <p:nvPr/>
-        </p:nvSpPr>
-        <p:spPr>
-          <a:xfrm>
-            <a:off x="8191500" y="3924300"/>
-            <a:ext cx="2794000" cy="342900"/>
-          </a:xfrm>
-          <a:prstGeom prst="rect">
-            <a:avLst/>
-          </a:prstGeom>
-          <a:noFill/>
-        </p:spPr>
-        <p:txBody>
-          <a:bodyPr wrap="square" lIns="0" rIns="0" tIns="0" bIns="0" anchor="ctr">
-            <a:spAutoFit/>
-          </a:bodyPr>
-          <a:lstStyle/>
-          <a:p>
-            <a:pPr algn="l">
-              <a:lnSpc>
-                <a:spcPts val="1600"/>
-              </a:lnSpc>
-            </a:pPr>
-            <a:r>
-              <a:rPr sz="1300" b="0">
-                <a:solidFill>
-                  <a:srgbClr val="FF6B3D"/>
-                </a:solidFill>
                 <a:latin typeface="Poppins"/>
               </a:rPr>
-              <a:t>[was gebaut wurde]</a:t>
-            </a:r>
-          </a:p>
-        </p:txBody>
-      </p:sp>
-      <p:sp>
-        <p:nvSpPr>
-          <p:cNvPr id="33" name="TextBox 32"/>
-          <p:cNvSpPr txBox="1"/>
-          <p:nvPr/>
-        </p:nvSpPr>
-        <p:spPr>
-          <a:xfrm>
-            <a:off x="8191500" y="4343400"/>
-            <a:ext cx="2794000" cy="127000"/>
-          </a:xfrm>
-          <a:prstGeom prst="rect">
-            <a:avLst/>
-          </a:prstGeom>
-          <a:noFill/>
-        </p:spPr>
-        <p:txBody>
-          <a:bodyPr wrap="square" lIns="0" rIns="0" tIns="0" bIns="0" anchor="ctr">
-            <a:spAutoFit/>
-          </a:bodyPr>
-          <a:lstStyle/>
-          <a:p>
-            <a:pPr algn="l"/>
-            <a:r>
-              <a:rPr sz="900" b="0" spc="200">
-                <a:solidFill>
-                  <a:srgbClr val="9A9AA2"/>
-                </a:solidFill>
-                <a:latin typeface="Courier New"/>
-              </a:rPr>
-              <a:t>RESULT</a:t>
-            </a:r>
-          </a:p>
-        </p:txBody>
-      </p:sp>
-      <p:sp>
-        <p:nvSpPr>
-          <p:cNvPr id="34" name="TextBox 33"/>
-          <p:cNvSpPr txBox="1"/>
-          <p:nvPr/>
-        </p:nvSpPr>
-        <p:spPr>
-          <a:xfrm>
-            <a:off x="8191500" y="4508500"/>
-            <a:ext cx="2794000" cy="342900"/>
-          </a:xfrm>
-          <a:prstGeom prst="rect">
-            <a:avLst/>
-          </a:prstGeom>
-          <a:noFill/>
-        </p:spPr>
-        <p:txBody>
-          <a:bodyPr wrap="square" lIns="0" rIns="0" tIns="0" bIns="0" anchor="ctr">
-            <a:spAutoFit/>
-          </a:bodyPr>
-          <a:lstStyle/>
-          <a:p>
-            <a:pPr algn="l">
-              <a:lnSpc>
-                <a:spcPts val="1600"/>
-              </a:lnSpc>
-            </a:pPr>
-            <a:r>
-              <a:rPr sz="1300" b="0">
-                <a:solidFill>
-                  <a:srgbClr val="FF6B3D"/>
-                </a:solidFill>
-                <a:latin typeface="Poppins"/>
-              </a:rPr>
-              <a:t>[Ergebnis in einer Zeile]</a:t>
-            </a:r>
-          </a:p>
-        </p:txBody>
-      </p:sp>
-      <p:sp>
-        <p:nvSpPr>
-          <p:cNvPr id="35" name="TextBox 34"/>
-          <p:cNvSpPr txBox="1"/>
-          <p:nvPr/>
-        </p:nvSpPr>
-        <p:spPr>
-          <a:xfrm>
-            <a:off x="698500" y="5257800"/>
-            <a:ext cx="9525000" cy="152400"/>
-          </a:xfrm>
-          <a:prstGeom prst="rect">
-            <a:avLst/>
-          </a:prstGeom>
-          <a:noFill/>
-        </p:spPr>
-        <p:txBody>
-          <a:bodyPr wrap="square" lIns="0" rIns="0" tIns="0" bIns="0" anchor="ctr">
-            <a:spAutoFit/>
-          </a:bodyPr>
-          <a:lstStyle/>
-          <a:p>
-            <a:pPr algn="l"/>
-            <a:r>
-              <a:rPr sz="1000" b="0">
-                <a:solidFill>
-                  <a:srgbClr val="FF6B3D"/>
-                </a:solidFill>
-                <a:latin typeface="Courier New"/>
-              </a:rPr>
-              <a:t>PLACEHOLDER — replace the three bracketed fields per tile before this deck goes to an investor.</a:t>
+              <a:t>  The library is what makes that safe.</a:t>
             </a:r>
           </a:p>
         </p:txBody>
       </p:sp>
       <p:pic>
         <p:nvPicPr>
-          <p:cNvPr id="36" name="Picture 35" descr="logo.png"/>
+          <p:cNvPr id="31" name="Picture 30" descr="logo.png"/>
           <p:cNvPicPr>
             <a:picLocks noChangeAspect="1"/>
           </p:cNvPicPr>
@@ -8021,7 +7867,7 @@
                 </a:solidFill>
                 <a:latin typeface="Poppins"/>
               </a:rPr>
-              <a:t>One question.</a:t>
+              <a:t>References.</a:t>
             </a:r>
             <a:r>
               <a:rPr sz="2700" b="0">
@@ -8030,7 +7876,7 @@
                 </a:solidFill>
                 <a:latin typeface="Poppins"/>
               </a:rPr>
-              <a:t> </a:t>
+              <a:t> Three builds, three problems.</a:t>
             </a:r>
           </a:p>
         </p:txBody>
@@ -8065,7 +7911,7 @@
                 </a:solidFill>
                 <a:latin typeface="Courier New"/>
               </a:rPr>
-              <a:t>08 — One question</a:t>
+              <a:t>08 — References</a:t>
             </a:r>
           </a:p>
         </p:txBody>
@@ -8122,8 +7968,8 @@
         </p:nvSpPr>
         <p:spPr>
           <a:xfrm>
-            <a:off x="698500" y="1854200"/>
-            <a:ext cx="8890000" cy="203200"/>
+            <a:off x="698500" y="1320800"/>
+            <a:ext cx="8890000" cy="190500"/>
           </a:xfrm>
           <a:prstGeom prst="rect">
             <a:avLst/>
@@ -8144,21 +7990,133 @@
                 </a:solidFill>
                 <a:latin typeface="Poppins"/>
               </a:rPr>
-              <a:t>Ich lasse Ihnen eine Frage da, keinen Prospekt.</a:t>
-            </a:r>
-          </a:p>
-        </p:txBody>
-      </p:sp>
-      <p:sp>
-        <p:nvSpPr>
-          <p:cNvPr id="7" name="TextBox 6"/>
-          <p:cNvSpPr txBox="1"/>
-          <p:nvPr/>
-        </p:nvSpPr>
-        <p:spPr>
-          <a:xfrm>
-            <a:off x="698500" y="2209800"/>
-            <a:ext cx="10287000" cy="1651000"/>
+              <a:t>Shipped software, not pilots. Each one replaced a process that was running manually.</a:t>
+            </a:r>
+          </a:p>
+        </p:txBody>
+      </p:sp>
+      <p:sp>
+        <p:nvSpPr>
+          <p:cNvPr id="7" name="Rectangle 6"/>
+          <p:cNvSpPr/>
+          <p:nvPr/>
+        </p:nvSpPr>
+        <p:spPr>
+          <a:xfrm>
+            <a:off x="698500" y="1828800"/>
+            <a:ext cx="10788650" cy="6350"/>
+          </a:xfrm>
+          <a:prstGeom prst="rect">
+            <a:avLst/>
+          </a:prstGeom>
+          <a:solidFill>
+            <a:srgbClr val="2B2B2D"/>
+          </a:solidFill>
+          <a:ln>
+            <a:noFill/>
+          </a:ln>
+          <a:effectLst/>
+        </p:spPr>
+        <p:style>
+          <a:lnRef idx="1">
+            <a:schemeClr val="accent1"/>
+          </a:lnRef>
+          <a:fillRef idx="3">
+            <a:schemeClr val="accent1"/>
+          </a:fillRef>
+          <a:effectRef idx="2">
+            <a:schemeClr val="accent1"/>
+          </a:effectRef>
+          <a:fontRef idx="minor">
+            <a:schemeClr val="lt1"/>
+          </a:fontRef>
+        </p:style>
+        <p:txBody>
+          <a:bodyPr rtlCol="0" anchor="ctr"/>
+          <a:lstStyle/>
+          <a:p>
+            <a:pPr algn="ctr"/>
+          </a:p>
+        </p:txBody>
+      </p:sp>
+      <p:sp>
+        <p:nvSpPr>
+          <p:cNvPr id="8" name="Rectangle 7"/>
+          <p:cNvSpPr/>
+          <p:nvPr/>
+        </p:nvSpPr>
+        <p:spPr>
+          <a:xfrm>
+            <a:off x="698500" y="2159000"/>
+            <a:ext cx="3302000" cy="2857500"/>
+          </a:xfrm>
+          <a:prstGeom prst="rect">
+            <a:avLst/>
+          </a:prstGeom>
+          <a:solidFill>
+            <a:srgbClr val="161619"/>
+          </a:solidFill>
+          <a:ln>
+            <a:noFill/>
+          </a:ln>
+          <a:effectLst/>
+        </p:spPr>
+        <p:style>
+          <a:lnRef idx="1">
+            <a:schemeClr val="accent1"/>
+          </a:lnRef>
+          <a:fillRef idx="3">
+            <a:schemeClr val="accent1"/>
+          </a:fillRef>
+          <a:effectRef idx="2">
+            <a:schemeClr val="accent1"/>
+          </a:effectRef>
+          <a:fontRef idx="minor">
+            <a:schemeClr val="lt1"/>
+          </a:fontRef>
+        </p:style>
+        <p:txBody>
+          <a:bodyPr rtlCol="0" anchor="ctr"/>
+          <a:lstStyle/>
+          <a:p>
+            <a:pPr algn="ctr"/>
+          </a:p>
+        </p:txBody>
+      </p:sp>
+      <p:pic>
+        <p:nvPicPr>
+          <p:cNvPr id="9" name="Picture 8" descr="ic-chart.png"/>
+          <p:cNvPicPr>
+            <a:picLocks noChangeAspect="1"/>
+          </p:cNvPicPr>
+          <p:nvPr/>
+        </p:nvPicPr>
+        <p:blipFill>
+          <a:blip r:embed="rId3"/>
+          <a:stretch>
+            <a:fillRect/>
+          </a:stretch>
+        </p:blipFill>
+        <p:spPr>
+          <a:xfrm>
+            <a:off x="952500" y="2400300"/>
+            <a:ext cx="215900" cy="215900"/>
+          </a:xfrm>
+          <a:prstGeom prst="rect">
+            <a:avLst/>
+          </a:prstGeom>
+        </p:spPr>
+      </p:pic>
+      <p:sp>
+        <p:nvSpPr>
+          <p:cNvPr id="10" name="TextBox 9"/>
+          <p:cNvSpPr txBox="1"/>
+          <p:nvPr/>
+        </p:nvSpPr>
+        <p:spPr>
+          <a:xfrm>
+            <a:off x="952500" y="2717800"/>
+            <a:ext cx="2794000" cy="279400"/>
           </a:xfrm>
           <a:prstGeom prst="rect">
             <a:avLst/>
@@ -8171,51 +8129,64 @@
           </a:bodyPr>
           <a:lstStyle/>
           <a:p>
-            <a:pPr algn="l">
-              <a:lnSpc>
-                <a:spcPts val="4400"/>
-              </a:lnSpc>
-            </a:pPr>
-            <a:r>
-              <a:rPr sz="3300" b="0">
+            <a:pPr algn="l"/>
+            <a:r>
+              <a:rPr sz="2000" b="0">
                 <a:solidFill>
                   <a:srgbClr val="ECECEE"/>
                 </a:solidFill>
                 <a:latin typeface="Poppins"/>
               </a:rPr>
-              <a:t>Welcher Prozess bei Ihnen läuft heute in </a:t>
-            </a:r>
-            <a:r>
-              <a:rPr sz="3300" b="0">
-                <a:solidFill>
-                  <a:srgbClr val="FF6B3D"/>
-                </a:solidFill>
-                <a:latin typeface="Poppins"/>
-              </a:rPr>
-              <a:t>Excel</a:t>
-            </a:r>
-            <a:r>
-              <a:rPr sz="3300" b="0">
-                <a:solidFill>
-                  <a:srgbClr val="ECECEE"/>
-                </a:solidFill>
-                <a:latin typeface="Poppins"/>
-              </a:rPr>
-              <a:t> und sollte es seit einem Jahr nicht mehr?</a:t>
-            </a:r>
-          </a:p>
-        </p:txBody>
-      </p:sp>
-      <p:sp>
-        <p:nvSpPr>
-          <p:cNvPr id="8" name="TextBox 7"/>
-          <p:cNvSpPr txBox="1"/>
-          <p:nvPr/>
-        </p:nvSpPr>
-        <p:spPr>
-          <a:xfrm>
-            <a:off x="698500" y="4241800"/>
-            <a:ext cx="8890000" cy="508000"/>
+              <a:t>CFO App</a:t>
+            </a:r>
+          </a:p>
+        </p:txBody>
+      </p:sp>
+      <p:sp>
+        <p:nvSpPr>
+          <p:cNvPr id="11" name="TextBox 10"/>
+          <p:cNvSpPr txBox="1"/>
+          <p:nvPr/>
+        </p:nvSpPr>
+        <p:spPr>
+          <a:xfrm>
+            <a:off x="952500" y="3175000"/>
+            <a:ext cx="2794000" cy="127000"/>
+          </a:xfrm>
+          <a:prstGeom prst="rect">
+            <a:avLst/>
+          </a:prstGeom>
+          <a:noFill/>
+        </p:spPr>
+        <p:txBody>
+          <a:bodyPr wrap="square" lIns="0" rIns="0" tIns="0" bIns="0" anchor="ctr">
+            <a:spAutoFit/>
+          </a:bodyPr>
+          <a:lstStyle/>
+          <a:p>
+            <a:pPr algn="l"/>
+            <a:r>
+              <a:rPr sz="900" b="0" spc="200">
+                <a:solidFill>
+                  <a:srgbClr val="9A9AA2"/>
+                </a:solidFill>
+                <a:latin typeface="Courier New"/>
+              </a:rPr>
+              <a:t>CLIENT / SECTOR</a:t>
+            </a:r>
+          </a:p>
+        </p:txBody>
+      </p:sp>
+      <p:sp>
+        <p:nvSpPr>
+          <p:cNvPr id="12" name="TextBox 11"/>
+          <p:cNvSpPr txBox="1"/>
+          <p:nvPr/>
+        </p:nvSpPr>
+        <p:spPr>
+          <a:xfrm>
+            <a:off x="952500" y="3340100"/>
+            <a:ext cx="2794000" cy="342900"/>
           </a:xfrm>
           <a:prstGeom prst="rect">
             <a:avLst/>
@@ -8234,27 +8205,27 @@
               </a:lnSpc>
             </a:pPr>
             <a:r>
-              <a:rPr sz="1200" b="0">
-                <a:solidFill>
-                  <a:srgbClr val="9A9AA2"/>
+              <a:rPr sz="1300" b="0">
+                <a:solidFill>
+                  <a:srgbClr val="FF6B3D"/>
                 </a:solidFill>
                 <a:latin typeface="Poppins"/>
               </a:rPr>
-              <a:t>Wenn Ihnen dazu gerade etwas eingefallen ist — sprechen Sie mich an. Wir machen daraus eine Anwendung. Und wenn Ihnen zwanzig einfallen, reden wir über die Plattform statt über die Anwendung.</a:t>
-            </a:r>
-          </a:p>
-        </p:txBody>
-      </p:sp>
-      <p:sp>
-        <p:nvSpPr>
-          <p:cNvPr id="9" name="TextBox 8"/>
-          <p:cNvSpPr txBox="1"/>
-          <p:nvPr/>
-        </p:nvSpPr>
-        <p:spPr>
-          <a:xfrm>
-            <a:off x="7042150" y="6032500"/>
-            <a:ext cx="4445000" cy="165100"/>
+              <a:t>[Kunde oder Branche]</a:t>
+            </a:r>
+          </a:p>
+        </p:txBody>
+      </p:sp>
+      <p:sp>
+        <p:nvSpPr>
+          <p:cNvPr id="13" name="TextBox 12"/>
+          <p:cNvSpPr txBox="1"/>
+          <p:nvPr/>
+        </p:nvSpPr>
+        <p:spPr>
+          <a:xfrm>
+            <a:off x="952500" y="3759200"/>
+            <a:ext cx="2794000" cy="127000"/>
           </a:xfrm>
           <a:prstGeom prst="rect">
             <a:avLst/>
@@ -8267,29 +8238,827 @@
           </a:bodyPr>
           <a:lstStyle/>
           <a:p>
-            <a:pPr algn="r"/>
-            <a:r>
-              <a:rPr sz="1000" b="0">
+            <a:pPr algn="l"/>
+            <a:r>
+              <a:rPr sz="900" b="0" spc="200">
+                <a:solidFill>
+                  <a:srgbClr val="9A9AA2"/>
+                </a:solidFill>
+                <a:latin typeface="Courier New"/>
+              </a:rPr>
+              <a:t>WHAT WE BUILT</a:t>
+            </a:r>
+          </a:p>
+        </p:txBody>
+      </p:sp>
+      <p:sp>
+        <p:nvSpPr>
+          <p:cNvPr id="14" name="TextBox 13"/>
+          <p:cNvSpPr txBox="1"/>
+          <p:nvPr/>
+        </p:nvSpPr>
+        <p:spPr>
+          <a:xfrm>
+            <a:off x="952500" y="3924300"/>
+            <a:ext cx="2794000" cy="342900"/>
+          </a:xfrm>
+          <a:prstGeom prst="rect">
+            <a:avLst/>
+          </a:prstGeom>
+          <a:noFill/>
+        </p:spPr>
+        <p:txBody>
+          <a:bodyPr wrap="square" lIns="0" rIns="0" tIns="0" bIns="0" anchor="ctr">
+            <a:spAutoFit/>
+          </a:bodyPr>
+          <a:lstStyle/>
+          <a:p>
+            <a:pPr algn="l">
+              <a:lnSpc>
+                <a:spcPts val="1600"/>
+              </a:lnSpc>
+            </a:pPr>
+            <a:r>
+              <a:rPr sz="1300" b="0">
                 <a:solidFill>
                   <a:srgbClr val="FF6B3D"/>
                 </a:solidFill>
+                <a:latin typeface="Poppins"/>
+              </a:rPr>
+              <a:t>[was gebaut wurde]</a:t>
+            </a:r>
+          </a:p>
+        </p:txBody>
+      </p:sp>
+      <p:sp>
+        <p:nvSpPr>
+          <p:cNvPr id="15" name="TextBox 14"/>
+          <p:cNvSpPr txBox="1"/>
+          <p:nvPr/>
+        </p:nvSpPr>
+        <p:spPr>
+          <a:xfrm>
+            <a:off x="952500" y="4343400"/>
+            <a:ext cx="2794000" cy="127000"/>
+          </a:xfrm>
+          <a:prstGeom prst="rect">
+            <a:avLst/>
+          </a:prstGeom>
+          <a:noFill/>
+        </p:spPr>
+        <p:txBody>
+          <a:bodyPr wrap="square" lIns="0" rIns="0" tIns="0" bIns="0" anchor="ctr">
+            <a:spAutoFit/>
+          </a:bodyPr>
+          <a:lstStyle/>
+          <a:p>
+            <a:pPr algn="l"/>
+            <a:r>
+              <a:rPr sz="900" b="0" spc="200">
+                <a:solidFill>
+                  <a:srgbClr val="9A9AA2"/>
+                </a:solidFill>
                 <a:latin typeface="Courier New"/>
               </a:rPr>
-              <a:t>[Name · E-Mail · Telefon]</a:t>
-            </a:r>
+              <a:t>RESULT</a:t>
+            </a:r>
+          </a:p>
+        </p:txBody>
+      </p:sp>
+      <p:sp>
+        <p:nvSpPr>
+          <p:cNvPr id="16" name="TextBox 15"/>
+          <p:cNvSpPr txBox="1"/>
+          <p:nvPr/>
+        </p:nvSpPr>
+        <p:spPr>
+          <a:xfrm>
+            <a:off x="952500" y="4508500"/>
+            <a:ext cx="2794000" cy="342900"/>
+          </a:xfrm>
+          <a:prstGeom prst="rect">
+            <a:avLst/>
+          </a:prstGeom>
+          <a:noFill/>
+        </p:spPr>
+        <p:txBody>
+          <a:bodyPr wrap="square" lIns="0" rIns="0" tIns="0" bIns="0" anchor="ctr">
+            <a:spAutoFit/>
+          </a:bodyPr>
+          <a:lstStyle/>
+          <a:p>
+            <a:pPr algn="l">
+              <a:lnSpc>
+                <a:spcPts val="1600"/>
+              </a:lnSpc>
+            </a:pPr>
+            <a:r>
+              <a:rPr sz="1300" b="0">
+                <a:solidFill>
+                  <a:srgbClr val="FF6B3D"/>
+                </a:solidFill>
+                <a:latin typeface="Poppins"/>
+              </a:rPr>
+              <a:t>[Ergebnis in einer Zeile]</a:t>
+            </a:r>
+          </a:p>
+        </p:txBody>
+      </p:sp>
+      <p:sp>
+        <p:nvSpPr>
+          <p:cNvPr id="17" name="Rectangle 16"/>
+          <p:cNvSpPr/>
+          <p:nvPr/>
+        </p:nvSpPr>
+        <p:spPr>
+          <a:xfrm>
+            <a:off x="4318000" y="2159000"/>
+            <a:ext cx="3302000" cy="2857500"/>
+          </a:xfrm>
+          <a:prstGeom prst="rect">
+            <a:avLst/>
+          </a:prstGeom>
+          <a:solidFill>
+            <a:srgbClr val="161619"/>
+          </a:solidFill>
+          <a:ln>
+            <a:noFill/>
+          </a:ln>
+          <a:effectLst/>
+        </p:spPr>
+        <p:style>
+          <a:lnRef idx="1">
+            <a:schemeClr val="accent1"/>
+          </a:lnRef>
+          <a:fillRef idx="3">
+            <a:schemeClr val="accent1"/>
+          </a:fillRef>
+          <a:effectRef idx="2">
+            <a:schemeClr val="accent1"/>
+          </a:effectRef>
+          <a:fontRef idx="minor">
+            <a:schemeClr val="lt1"/>
+          </a:fontRef>
+        </p:style>
+        <p:txBody>
+          <a:bodyPr rtlCol="0" anchor="ctr"/>
+          <a:lstStyle/>
+          <a:p>
+            <a:pPr algn="ctr"/>
           </a:p>
         </p:txBody>
       </p:sp>
       <p:pic>
         <p:nvPicPr>
-          <p:cNvPr id="10" name="Picture 9" descr="logo.png"/>
+          <p:cNvPr id="18" name="Picture 17" descr="ic-funnel.png"/>
           <p:cNvPicPr>
             <a:picLocks noChangeAspect="1"/>
           </p:cNvPicPr>
           <p:nvPr/>
         </p:nvPicPr>
         <p:blipFill>
-          <a:blip r:embed="rId3"/>
+          <a:blip r:embed="rId4"/>
+          <a:stretch>
+            <a:fillRect/>
+          </a:stretch>
+        </p:blipFill>
+        <p:spPr>
+          <a:xfrm>
+            <a:off x="4572000" y="2400300"/>
+            <a:ext cx="215900" cy="215900"/>
+          </a:xfrm>
+          <a:prstGeom prst="rect">
+            <a:avLst/>
+          </a:prstGeom>
+        </p:spPr>
+      </p:pic>
+      <p:sp>
+        <p:nvSpPr>
+          <p:cNvPr id="19" name="TextBox 18"/>
+          <p:cNvSpPr txBox="1"/>
+          <p:nvPr/>
+        </p:nvSpPr>
+        <p:spPr>
+          <a:xfrm>
+            <a:off x="4572000" y="2717800"/>
+            <a:ext cx="2794000" cy="279400"/>
+          </a:xfrm>
+          <a:prstGeom prst="rect">
+            <a:avLst/>
+          </a:prstGeom>
+          <a:noFill/>
+        </p:spPr>
+        <p:txBody>
+          <a:bodyPr wrap="square" lIns="0" rIns="0" tIns="0" bIns="0" anchor="ctr">
+            <a:spAutoFit/>
+          </a:bodyPr>
+          <a:lstStyle/>
+          <a:p>
+            <a:pPr algn="l"/>
+            <a:r>
+              <a:rPr sz="2000" b="0">
+                <a:solidFill>
+                  <a:srgbClr val="ECECEE"/>
+                </a:solidFill>
+                <a:latin typeface="Poppins"/>
+              </a:rPr>
+              <a:t>Lead Generation</a:t>
+            </a:r>
+          </a:p>
+        </p:txBody>
+      </p:sp>
+      <p:sp>
+        <p:nvSpPr>
+          <p:cNvPr id="20" name="TextBox 19"/>
+          <p:cNvSpPr txBox="1"/>
+          <p:nvPr/>
+        </p:nvSpPr>
+        <p:spPr>
+          <a:xfrm>
+            <a:off x="4572000" y="3175000"/>
+            <a:ext cx="2794000" cy="127000"/>
+          </a:xfrm>
+          <a:prstGeom prst="rect">
+            <a:avLst/>
+          </a:prstGeom>
+          <a:noFill/>
+        </p:spPr>
+        <p:txBody>
+          <a:bodyPr wrap="square" lIns="0" rIns="0" tIns="0" bIns="0" anchor="ctr">
+            <a:spAutoFit/>
+          </a:bodyPr>
+          <a:lstStyle/>
+          <a:p>
+            <a:pPr algn="l"/>
+            <a:r>
+              <a:rPr sz="900" b="0" spc="200">
+                <a:solidFill>
+                  <a:srgbClr val="9A9AA2"/>
+                </a:solidFill>
+                <a:latin typeface="Courier New"/>
+              </a:rPr>
+              <a:t>CLIENT / SECTOR</a:t>
+            </a:r>
+          </a:p>
+        </p:txBody>
+      </p:sp>
+      <p:sp>
+        <p:nvSpPr>
+          <p:cNvPr id="21" name="TextBox 20"/>
+          <p:cNvSpPr txBox="1"/>
+          <p:nvPr/>
+        </p:nvSpPr>
+        <p:spPr>
+          <a:xfrm>
+            <a:off x="4572000" y="3340100"/>
+            <a:ext cx="2794000" cy="342900"/>
+          </a:xfrm>
+          <a:prstGeom prst="rect">
+            <a:avLst/>
+          </a:prstGeom>
+          <a:noFill/>
+        </p:spPr>
+        <p:txBody>
+          <a:bodyPr wrap="square" lIns="0" rIns="0" tIns="0" bIns="0" anchor="ctr">
+            <a:spAutoFit/>
+          </a:bodyPr>
+          <a:lstStyle/>
+          <a:p>
+            <a:pPr algn="l">
+              <a:lnSpc>
+                <a:spcPts val="1600"/>
+              </a:lnSpc>
+            </a:pPr>
+            <a:r>
+              <a:rPr sz="1300" b="0">
+                <a:solidFill>
+                  <a:srgbClr val="FF6B3D"/>
+                </a:solidFill>
+                <a:latin typeface="Poppins"/>
+              </a:rPr>
+              <a:t>[Kunde oder Branche]</a:t>
+            </a:r>
+          </a:p>
+        </p:txBody>
+      </p:sp>
+      <p:sp>
+        <p:nvSpPr>
+          <p:cNvPr id="22" name="TextBox 21"/>
+          <p:cNvSpPr txBox="1"/>
+          <p:nvPr/>
+        </p:nvSpPr>
+        <p:spPr>
+          <a:xfrm>
+            <a:off x="4572000" y="3759200"/>
+            <a:ext cx="2794000" cy="127000"/>
+          </a:xfrm>
+          <a:prstGeom prst="rect">
+            <a:avLst/>
+          </a:prstGeom>
+          <a:noFill/>
+        </p:spPr>
+        <p:txBody>
+          <a:bodyPr wrap="square" lIns="0" rIns="0" tIns="0" bIns="0" anchor="ctr">
+            <a:spAutoFit/>
+          </a:bodyPr>
+          <a:lstStyle/>
+          <a:p>
+            <a:pPr algn="l"/>
+            <a:r>
+              <a:rPr sz="900" b="0" spc="200">
+                <a:solidFill>
+                  <a:srgbClr val="9A9AA2"/>
+                </a:solidFill>
+                <a:latin typeface="Courier New"/>
+              </a:rPr>
+              <a:t>WHAT WE BUILT</a:t>
+            </a:r>
+          </a:p>
+        </p:txBody>
+      </p:sp>
+      <p:sp>
+        <p:nvSpPr>
+          <p:cNvPr id="23" name="TextBox 22"/>
+          <p:cNvSpPr txBox="1"/>
+          <p:nvPr/>
+        </p:nvSpPr>
+        <p:spPr>
+          <a:xfrm>
+            <a:off x="4572000" y="3924300"/>
+            <a:ext cx="2794000" cy="342900"/>
+          </a:xfrm>
+          <a:prstGeom prst="rect">
+            <a:avLst/>
+          </a:prstGeom>
+          <a:noFill/>
+        </p:spPr>
+        <p:txBody>
+          <a:bodyPr wrap="square" lIns="0" rIns="0" tIns="0" bIns="0" anchor="ctr">
+            <a:spAutoFit/>
+          </a:bodyPr>
+          <a:lstStyle/>
+          <a:p>
+            <a:pPr algn="l">
+              <a:lnSpc>
+                <a:spcPts val="1600"/>
+              </a:lnSpc>
+            </a:pPr>
+            <a:r>
+              <a:rPr sz="1300" b="0">
+                <a:solidFill>
+                  <a:srgbClr val="FF6B3D"/>
+                </a:solidFill>
+                <a:latin typeface="Poppins"/>
+              </a:rPr>
+              <a:t>[was gebaut wurde]</a:t>
+            </a:r>
+          </a:p>
+        </p:txBody>
+      </p:sp>
+      <p:sp>
+        <p:nvSpPr>
+          <p:cNvPr id="24" name="TextBox 23"/>
+          <p:cNvSpPr txBox="1"/>
+          <p:nvPr/>
+        </p:nvSpPr>
+        <p:spPr>
+          <a:xfrm>
+            <a:off x="4572000" y="4343400"/>
+            <a:ext cx="2794000" cy="127000"/>
+          </a:xfrm>
+          <a:prstGeom prst="rect">
+            <a:avLst/>
+          </a:prstGeom>
+          <a:noFill/>
+        </p:spPr>
+        <p:txBody>
+          <a:bodyPr wrap="square" lIns="0" rIns="0" tIns="0" bIns="0" anchor="ctr">
+            <a:spAutoFit/>
+          </a:bodyPr>
+          <a:lstStyle/>
+          <a:p>
+            <a:pPr algn="l"/>
+            <a:r>
+              <a:rPr sz="900" b="0" spc="200">
+                <a:solidFill>
+                  <a:srgbClr val="9A9AA2"/>
+                </a:solidFill>
+                <a:latin typeface="Courier New"/>
+              </a:rPr>
+              <a:t>RESULT</a:t>
+            </a:r>
+          </a:p>
+        </p:txBody>
+      </p:sp>
+      <p:sp>
+        <p:nvSpPr>
+          <p:cNvPr id="25" name="TextBox 24"/>
+          <p:cNvSpPr txBox="1"/>
+          <p:nvPr/>
+        </p:nvSpPr>
+        <p:spPr>
+          <a:xfrm>
+            <a:off x="4572000" y="4508500"/>
+            <a:ext cx="2794000" cy="342900"/>
+          </a:xfrm>
+          <a:prstGeom prst="rect">
+            <a:avLst/>
+          </a:prstGeom>
+          <a:noFill/>
+        </p:spPr>
+        <p:txBody>
+          <a:bodyPr wrap="square" lIns="0" rIns="0" tIns="0" bIns="0" anchor="ctr">
+            <a:spAutoFit/>
+          </a:bodyPr>
+          <a:lstStyle/>
+          <a:p>
+            <a:pPr algn="l">
+              <a:lnSpc>
+                <a:spcPts val="1600"/>
+              </a:lnSpc>
+            </a:pPr>
+            <a:r>
+              <a:rPr sz="1300" b="0">
+                <a:solidFill>
+                  <a:srgbClr val="FF6B3D"/>
+                </a:solidFill>
+                <a:latin typeface="Poppins"/>
+              </a:rPr>
+              <a:t>[Ergebnis in einer Zeile]</a:t>
+            </a:r>
+          </a:p>
+        </p:txBody>
+      </p:sp>
+      <p:sp>
+        <p:nvSpPr>
+          <p:cNvPr id="26" name="Rectangle 25"/>
+          <p:cNvSpPr/>
+          <p:nvPr/>
+        </p:nvSpPr>
+        <p:spPr>
+          <a:xfrm>
+            <a:off x="7937500" y="2159000"/>
+            <a:ext cx="3302000" cy="2857500"/>
+          </a:xfrm>
+          <a:prstGeom prst="rect">
+            <a:avLst/>
+          </a:prstGeom>
+          <a:solidFill>
+            <a:srgbClr val="161619"/>
+          </a:solidFill>
+          <a:ln>
+            <a:noFill/>
+          </a:ln>
+          <a:effectLst/>
+        </p:spPr>
+        <p:style>
+          <a:lnRef idx="1">
+            <a:schemeClr val="accent1"/>
+          </a:lnRef>
+          <a:fillRef idx="3">
+            <a:schemeClr val="accent1"/>
+          </a:fillRef>
+          <a:effectRef idx="2">
+            <a:schemeClr val="accent1"/>
+          </a:effectRef>
+          <a:fontRef idx="minor">
+            <a:schemeClr val="lt1"/>
+          </a:fontRef>
+        </p:style>
+        <p:txBody>
+          <a:bodyPr rtlCol="0" anchor="ctr"/>
+          <a:lstStyle/>
+          <a:p>
+            <a:pPr algn="ctr"/>
+          </a:p>
+        </p:txBody>
+      </p:sp>
+      <p:pic>
+        <p:nvPicPr>
+          <p:cNvPr id="27" name="Picture 26" descr="ic-bubble.png"/>
+          <p:cNvPicPr>
+            <a:picLocks noChangeAspect="1"/>
+          </p:cNvPicPr>
+          <p:nvPr/>
+        </p:nvPicPr>
+        <p:blipFill>
+          <a:blip r:embed="rId5"/>
+          <a:stretch>
+            <a:fillRect/>
+          </a:stretch>
+        </p:blipFill>
+        <p:spPr>
+          <a:xfrm>
+            <a:off x="8191500" y="2400300"/>
+            <a:ext cx="215900" cy="215900"/>
+          </a:xfrm>
+          <a:prstGeom prst="rect">
+            <a:avLst/>
+          </a:prstGeom>
+        </p:spPr>
+      </p:pic>
+      <p:sp>
+        <p:nvSpPr>
+          <p:cNvPr id="28" name="TextBox 27"/>
+          <p:cNvSpPr txBox="1"/>
+          <p:nvPr/>
+        </p:nvSpPr>
+        <p:spPr>
+          <a:xfrm>
+            <a:off x="8191500" y="2717800"/>
+            <a:ext cx="2794000" cy="279400"/>
+          </a:xfrm>
+          <a:prstGeom prst="rect">
+            <a:avLst/>
+          </a:prstGeom>
+          <a:noFill/>
+        </p:spPr>
+        <p:txBody>
+          <a:bodyPr wrap="square" lIns="0" rIns="0" tIns="0" bIns="0" anchor="ctr">
+            <a:spAutoFit/>
+          </a:bodyPr>
+          <a:lstStyle/>
+          <a:p>
+            <a:pPr algn="l"/>
+            <a:r>
+              <a:rPr sz="2000" b="0">
+                <a:solidFill>
+                  <a:srgbClr val="ECECEE"/>
+                </a:solidFill>
+                <a:latin typeface="Poppins"/>
+              </a:rPr>
+              <a:t>Board Assistant</a:t>
+            </a:r>
+          </a:p>
+        </p:txBody>
+      </p:sp>
+      <p:sp>
+        <p:nvSpPr>
+          <p:cNvPr id="29" name="TextBox 28"/>
+          <p:cNvSpPr txBox="1"/>
+          <p:nvPr/>
+        </p:nvSpPr>
+        <p:spPr>
+          <a:xfrm>
+            <a:off x="8191500" y="3175000"/>
+            <a:ext cx="2794000" cy="127000"/>
+          </a:xfrm>
+          <a:prstGeom prst="rect">
+            <a:avLst/>
+          </a:prstGeom>
+          <a:noFill/>
+        </p:spPr>
+        <p:txBody>
+          <a:bodyPr wrap="square" lIns="0" rIns="0" tIns="0" bIns="0" anchor="ctr">
+            <a:spAutoFit/>
+          </a:bodyPr>
+          <a:lstStyle/>
+          <a:p>
+            <a:pPr algn="l"/>
+            <a:r>
+              <a:rPr sz="900" b="0" spc="200">
+                <a:solidFill>
+                  <a:srgbClr val="9A9AA2"/>
+                </a:solidFill>
+                <a:latin typeface="Courier New"/>
+              </a:rPr>
+              <a:t>CLIENT / SECTOR</a:t>
+            </a:r>
+          </a:p>
+        </p:txBody>
+      </p:sp>
+      <p:sp>
+        <p:nvSpPr>
+          <p:cNvPr id="30" name="TextBox 29"/>
+          <p:cNvSpPr txBox="1"/>
+          <p:nvPr/>
+        </p:nvSpPr>
+        <p:spPr>
+          <a:xfrm>
+            <a:off x="8191500" y="3340100"/>
+            <a:ext cx="2794000" cy="342900"/>
+          </a:xfrm>
+          <a:prstGeom prst="rect">
+            <a:avLst/>
+          </a:prstGeom>
+          <a:noFill/>
+        </p:spPr>
+        <p:txBody>
+          <a:bodyPr wrap="square" lIns="0" rIns="0" tIns="0" bIns="0" anchor="ctr">
+            <a:spAutoFit/>
+          </a:bodyPr>
+          <a:lstStyle/>
+          <a:p>
+            <a:pPr algn="l">
+              <a:lnSpc>
+                <a:spcPts val="1600"/>
+              </a:lnSpc>
+            </a:pPr>
+            <a:r>
+              <a:rPr sz="1300" b="0">
+                <a:solidFill>
+                  <a:srgbClr val="FF6B3D"/>
+                </a:solidFill>
+                <a:latin typeface="Poppins"/>
+              </a:rPr>
+              <a:t>[Kunde oder Branche]</a:t>
+            </a:r>
+          </a:p>
+        </p:txBody>
+      </p:sp>
+      <p:sp>
+        <p:nvSpPr>
+          <p:cNvPr id="31" name="TextBox 30"/>
+          <p:cNvSpPr txBox="1"/>
+          <p:nvPr/>
+        </p:nvSpPr>
+        <p:spPr>
+          <a:xfrm>
+            <a:off x="8191500" y="3759200"/>
+            <a:ext cx="2794000" cy="127000"/>
+          </a:xfrm>
+          <a:prstGeom prst="rect">
+            <a:avLst/>
+          </a:prstGeom>
+          <a:noFill/>
+        </p:spPr>
+        <p:txBody>
+          <a:bodyPr wrap="square" lIns="0" rIns="0" tIns="0" bIns="0" anchor="ctr">
+            <a:spAutoFit/>
+          </a:bodyPr>
+          <a:lstStyle/>
+          <a:p>
+            <a:pPr algn="l"/>
+            <a:r>
+              <a:rPr sz="900" b="0" spc="200">
+                <a:solidFill>
+                  <a:srgbClr val="9A9AA2"/>
+                </a:solidFill>
+                <a:latin typeface="Courier New"/>
+              </a:rPr>
+              <a:t>WHAT WE BUILT</a:t>
+            </a:r>
+          </a:p>
+        </p:txBody>
+      </p:sp>
+      <p:sp>
+        <p:nvSpPr>
+          <p:cNvPr id="32" name="TextBox 31"/>
+          <p:cNvSpPr txBox="1"/>
+          <p:nvPr/>
+        </p:nvSpPr>
+        <p:spPr>
+          <a:xfrm>
+            <a:off x="8191500" y="3924300"/>
+            <a:ext cx="2794000" cy="342900"/>
+          </a:xfrm>
+          <a:prstGeom prst="rect">
+            <a:avLst/>
+          </a:prstGeom>
+          <a:noFill/>
+        </p:spPr>
+        <p:txBody>
+          <a:bodyPr wrap="square" lIns="0" rIns="0" tIns="0" bIns="0" anchor="ctr">
+            <a:spAutoFit/>
+          </a:bodyPr>
+          <a:lstStyle/>
+          <a:p>
+            <a:pPr algn="l">
+              <a:lnSpc>
+                <a:spcPts val="1600"/>
+              </a:lnSpc>
+            </a:pPr>
+            <a:r>
+              <a:rPr sz="1300" b="0">
+                <a:solidFill>
+                  <a:srgbClr val="FF6B3D"/>
+                </a:solidFill>
+                <a:latin typeface="Poppins"/>
+              </a:rPr>
+              <a:t>[was gebaut wurde]</a:t>
+            </a:r>
+          </a:p>
+        </p:txBody>
+      </p:sp>
+      <p:sp>
+        <p:nvSpPr>
+          <p:cNvPr id="33" name="TextBox 32"/>
+          <p:cNvSpPr txBox="1"/>
+          <p:nvPr/>
+        </p:nvSpPr>
+        <p:spPr>
+          <a:xfrm>
+            <a:off x="8191500" y="4343400"/>
+            <a:ext cx="2794000" cy="127000"/>
+          </a:xfrm>
+          <a:prstGeom prst="rect">
+            <a:avLst/>
+          </a:prstGeom>
+          <a:noFill/>
+        </p:spPr>
+        <p:txBody>
+          <a:bodyPr wrap="square" lIns="0" rIns="0" tIns="0" bIns="0" anchor="ctr">
+            <a:spAutoFit/>
+          </a:bodyPr>
+          <a:lstStyle/>
+          <a:p>
+            <a:pPr algn="l"/>
+            <a:r>
+              <a:rPr sz="900" b="0" spc="200">
+                <a:solidFill>
+                  <a:srgbClr val="9A9AA2"/>
+                </a:solidFill>
+                <a:latin typeface="Courier New"/>
+              </a:rPr>
+              <a:t>RESULT</a:t>
+            </a:r>
+          </a:p>
+        </p:txBody>
+      </p:sp>
+      <p:sp>
+        <p:nvSpPr>
+          <p:cNvPr id="34" name="TextBox 33"/>
+          <p:cNvSpPr txBox="1"/>
+          <p:nvPr/>
+        </p:nvSpPr>
+        <p:spPr>
+          <a:xfrm>
+            <a:off x="8191500" y="4508500"/>
+            <a:ext cx="2794000" cy="342900"/>
+          </a:xfrm>
+          <a:prstGeom prst="rect">
+            <a:avLst/>
+          </a:prstGeom>
+          <a:noFill/>
+        </p:spPr>
+        <p:txBody>
+          <a:bodyPr wrap="square" lIns="0" rIns="0" tIns="0" bIns="0" anchor="ctr">
+            <a:spAutoFit/>
+          </a:bodyPr>
+          <a:lstStyle/>
+          <a:p>
+            <a:pPr algn="l">
+              <a:lnSpc>
+                <a:spcPts val="1600"/>
+              </a:lnSpc>
+            </a:pPr>
+            <a:r>
+              <a:rPr sz="1300" b="0">
+                <a:solidFill>
+                  <a:srgbClr val="FF6B3D"/>
+                </a:solidFill>
+                <a:latin typeface="Poppins"/>
+              </a:rPr>
+              <a:t>[Ergebnis in einer Zeile]</a:t>
+            </a:r>
+          </a:p>
+        </p:txBody>
+      </p:sp>
+      <p:sp>
+        <p:nvSpPr>
+          <p:cNvPr id="35" name="TextBox 34"/>
+          <p:cNvSpPr txBox="1"/>
+          <p:nvPr/>
+        </p:nvSpPr>
+        <p:spPr>
+          <a:xfrm>
+            <a:off x="698500" y="5257800"/>
+            <a:ext cx="9525000" cy="152400"/>
+          </a:xfrm>
+          <a:prstGeom prst="rect">
+            <a:avLst/>
+          </a:prstGeom>
+          <a:noFill/>
+        </p:spPr>
+        <p:txBody>
+          <a:bodyPr wrap="square" lIns="0" rIns="0" tIns="0" bIns="0" anchor="ctr">
+            <a:spAutoFit/>
+          </a:bodyPr>
+          <a:lstStyle/>
+          <a:p>
+            <a:pPr algn="l"/>
+            <a:r>
+              <a:rPr sz="1000" b="0">
+                <a:solidFill>
+                  <a:srgbClr val="FF6B3D"/>
+                </a:solidFill>
+                <a:latin typeface="Courier New"/>
+              </a:rPr>
+              <a:t>PLACEHOLDER — replace the three bracketed fields per tile before this deck goes to an investor.</a:t>
+            </a:r>
+          </a:p>
+        </p:txBody>
+      </p:sp>
+      <p:pic>
+        <p:nvPicPr>
+          <p:cNvPr id="36" name="Picture 35" descr="logo.png"/>
+          <p:cNvPicPr>
+            <a:picLocks noChangeAspect="1"/>
+          </p:cNvPicPr>
+          <p:nvPr/>
+        </p:nvPicPr>
+        <p:blipFill>
+          <a:blip r:embed="rId6"/>
           <a:stretch>
             <a:fillRect/>
           </a:stretch>
@@ -8376,7 +9145,7 @@
                 </a:solidFill>
                 <a:latin typeface="Poppins"/>
               </a:rPr>
-              <a:t>Further questions.</a:t>
+              <a:t>One question.</a:t>
             </a:r>
             <a:r>
               <a:rPr sz="2700" b="0">
@@ -8420,7 +9189,362 @@
                 </a:solidFill>
                 <a:latin typeface="Courier New"/>
               </a:rPr>
-              <a:t>09 — Appendix</a:t>
+              <a:t>09 — One question</a:t>
+            </a:r>
+          </a:p>
+        </p:txBody>
+      </p:sp>
+      <p:sp>
+        <p:nvSpPr>
+          <p:cNvPr id="5" name="Rectangle 4"/>
+          <p:cNvSpPr/>
+          <p:nvPr/>
+        </p:nvSpPr>
+        <p:spPr>
+          <a:xfrm>
+            <a:off x="698500" y="1092200"/>
+            <a:ext cx="10788650" cy="6350"/>
+          </a:xfrm>
+          <a:prstGeom prst="rect">
+            <a:avLst/>
+          </a:prstGeom>
+          <a:solidFill>
+            <a:srgbClr val="2B2B2D"/>
+          </a:solidFill>
+          <a:ln>
+            <a:noFill/>
+          </a:ln>
+          <a:effectLst/>
+        </p:spPr>
+        <p:style>
+          <a:lnRef idx="1">
+            <a:schemeClr val="accent1"/>
+          </a:lnRef>
+          <a:fillRef idx="3">
+            <a:schemeClr val="accent1"/>
+          </a:fillRef>
+          <a:effectRef idx="2">
+            <a:schemeClr val="accent1"/>
+          </a:effectRef>
+          <a:fontRef idx="minor">
+            <a:schemeClr val="lt1"/>
+          </a:fontRef>
+        </p:style>
+        <p:txBody>
+          <a:bodyPr rtlCol="0" anchor="ctr"/>
+          <a:lstStyle/>
+          <a:p>
+            <a:pPr algn="ctr"/>
+          </a:p>
+        </p:txBody>
+      </p:sp>
+      <p:sp>
+        <p:nvSpPr>
+          <p:cNvPr id="6" name="TextBox 5"/>
+          <p:cNvSpPr txBox="1"/>
+          <p:nvPr/>
+        </p:nvSpPr>
+        <p:spPr>
+          <a:xfrm>
+            <a:off x="698500" y="1854200"/>
+            <a:ext cx="8890000" cy="203200"/>
+          </a:xfrm>
+          <a:prstGeom prst="rect">
+            <a:avLst/>
+          </a:prstGeom>
+          <a:noFill/>
+        </p:spPr>
+        <p:txBody>
+          <a:bodyPr wrap="square" lIns="0" rIns="0" tIns="0" bIns="0" anchor="ctr">
+            <a:spAutoFit/>
+          </a:bodyPr>
+          <a:lstStyle/>
+          <a:p>
+            <a:pPr algn="l"/>
+            <a:r>
+              <a:rPr sz="1400" b="0">
+                <a:solidFill>
+                  <a:srgbClr val="9A9AA2"/>
+                </a:solidFill>
+                <a:latin typeface="Poppins"/>
+              </a:rPr>
+              <a:t>Ich lasse Ihnen eine Frage da, keinen Prospekt.</a:t>
+            </a:r>
+          </a:p>
+        </p:txBody>
+      </p:sp>
+      <p:sp>
+        <p:nvSpPr>
+          <p:cNvPr id="7" name="TextBox 6"/>
+          <p:cNvSpPr txBox="1"/>
+          <p:nvPr/>
+        </p:nvSpPr>
+        <p:spPr>
+          <a:xfrm>
+            <a:off x="698500" y="2209800"/>
+            <a:ext cx="10287000" cy="1651000"/>
+          </a:xfrm>
+          <a:prstGeom prst="rect">
+            <a:avLst/>
+          </a:prstGeom>
+          <a:noFill/>
+        </p:spPr>
+        <p:txBody>
+          <a:bodyPr wrap="square" lIns="0" rIns="0" tIns="0" bIns="0" anchor="ctr">
+            <a:spAutoFit/>
+          </a:bodyPr>
+          <a:lstStyle/>
+          <a:p>
+            <a:pPr algn="l">
+              <a:lnSpc>
+                <a:spcPts val="4400"/>
+              </a:lnSpc>
+            </a:pPr>
+            <a:r>
+              <a:rPr sz="3300" b="0">
+                <a:solidFill>
+                  <a:srgbClr val="ECECEE"/>
+                </a:solidFill>
+                <a:latin typeface="Poppins"/>
+              </a:rPr>
+              <a:t>Welcher Prozess bei Ihnen läuft heute in </a:t>
+            </a:r>
+            <a:r>
+              <a:rPr sz="3300" b="0">
+                <a:solidFill>
+                  <a:srgbClr val="FF6B3D"/>
+                </a:solidFill>
+                <a:latin typeface="Poppins"/>
+              </a:rPr>
+              <a:t>Excel</a:t>
+            </a:r>
+            <a:r>
+              <a:rPr sz="3300" b="0">
+                <a:solidFill>
+                  <a:srgbClr val="ECECEE"/>
+                </a:solidFill>
+                <a:latin typeface="Poppins"/>
+              </a:rPr>
+              <a:t> und sollte es seit einem Jahr nicht mehr?</a:t>
+            </a:r>
+          </a:p>
+        </p:txBody>
+      </p:sp>
+      <p:sp>
+        <p:nvSpPr>
+          <p:cNvPr id="8" name="TextBox 7"/>
+          <p:cNvSpPr txBox="1"/>
+          <p:nvPr/>
+        </p:nvSpPr>
+        <p:spPr>
+          <a:xfrm>
+            <a:off x="698500" y="4241800"/>
+            <a:ext cx="8890000" cy="508000"/>
+          </a:xfrm>
+          <a:prstGeom prst="rect">
+            <a:avLst/>
+          </a:prstGeom>
+          <a:noFill/>
+        </p:spPr>
+        <p:txBody>
+          <a:bodyPr wrap="square" lIns="0" rIns="0" tIns="0" bIns="0" anchor="ctr">
+            <a:spAutoFit/>
+          </a:bodyPr>
+          <a:lstStyle/>
+          <a:p>
+            <a:pPr algn="l">
+              <a:lnSpc>
+                <a:spcPts val="1600"/>
+              </a:lnSpc>
+            </a:pPr>
+            <a:r>
+              <a:rPr sz="1200" b="0">
+                <a:solidFill>
+                  <a:srgbClr val="9A9AA2"/>
+                </a:solidFill>
+                <a:latin typeface="Poppins"/>
+              </a:rPr>
+              <a:t>Wenn Ihnen dazu gerade etwas eingefallen ist — sprechen Sie mich an. Wir machen daraus eine Anwendung. Und wenn Ihnen zwanzig einfallen, reden wir über die Plattform statt über die Anwendung.</a:t>
+            </a:r>
+          </a:p>
+        </p:txBody>
+      </p:sp>
+      <p:sp>
+        <p:nvSpPr>
+          <p:cNvPr id="9" name="TextBox 8"/>
+          <p:cNvSpPr txBox="1"/>
+          <p:nvPr/>
+        </p:nvSpPr>
+        <p:spPr>
+          <a:xfrm>
+            <a:off x="7042150" y="6032500"/>
+            <a:ext cx="4445000" cy="165100"/>
+          </a:xfrm>
+          <a:prstGeom prst="rect">
+            <a:avLst/>
+          </a:prstGeom>
+          <a:noFill/>
+        </p:spPr>
+        <p:txBody>
+          <a:bodyPr wrap="square" lIns="0" rIns="0" tIns="0" bIns="0" anchor="ctr">
+            <a:spAutoFit/>
+          </a:bodyPr>
+          <a:lstStyle/>
+          <a:p>
+            <a:pPr algn="r"/>
+            <a:r>
+              <a:rPr sz="1000" b="0">
+                <a:solidFill>
+                  <a:srgbClr val="FF6B3D"/>
+                </a:solidFill>
+                <a:latin typeface="Courier New"/>
+              </a:rPr>
+              <a:t>[Name · E-Mail · Telefon]</a:t>
+            </a:r>
+          </a:p>
+        </p:txBody>
+      </p:sp>
+      <p:pic>
+        <p:nvPicPr>
+          <p:cNvPr id="10" name="Picture 9" descr="logo.png"/>
+          <p:cNvPicPr>
+            <a:picLocks noChangeAspect="1"/>
+          </p:cNvPicPr>
+          <p:nvPr/>
+        </p:nvPicPr>
+        <p:blipFill>
+          <a:blip r:embed="rId3"/>
+          <a:stretch>
+            <a:fillRect/>
+          </a:stretch>
+        </p:blipFill>
+        <p:spPr>
+          <a:xfrm>
+            <a:off x="635000" y="6438900"/>
+            <a:ext cx="1079500" cy="254000"/>
+          </a:xfrm>
+          <a:prstGeom prst="rect">
+            <a:avLst/>
+          </a:prstGeom>
+        </p:spPr>
+      </p:pic>
+    </p:spTree>
+  </p:cSld>
+  <p:clrMapOvr>
+    <a:masterClrMapping/>
+  </p:clrMapOvr>
+</p:sld>
+</file>
+
+<file path=ppt/slides/slide15.xml><?xml version="1.0" encoding="utf-8"?>
+<p:sld xmlns:a="http://schemas.openxmlformats.org/drawingml/2006/main" xmlns:p="http://schemas.openxmlformats.org/presentationml/2006/main" xmlns:r="http://schemas.openxmlformats.org/officeDocument/2006/relationships">
+  <p:cSld>
+    <p:spTree>
+      <p:nvGrpSpPr>
+        <p:cNvPr id="1" name=""/>
+        <p:cNvGrpSpPr/>
+        <p:nvPr/>
+      </p:nvGrpSpPr>
+      <p:grpSpPr/>
+      <p:pic>
+        <p:nvPicPr>
+          <p:cNvPr id="2" name="Picture 1" descr="image.png"/>
+          <p:cNvPicPr>
+            <a:picLocks noChangeAspect="1"/>
+          </p:cNvPicPr>
+          <p:nvPr/>
+        </p:nvPicPr>
+        <p:blipFill>
+          <a:blip r:embed="rId2"/>
+          <a:stretch>
+            <a:fillRect/>
+          </a:stretch>
+        </p:blipFill>
+        <p:spPr>
+          <a:xfrm>
+            <a:off x="0" y="0"/>
+            <a:ext cx="12192000" cy="6858000"/>
+          </a:xfrm>
+          <a:prstGeom prst="rect">
+            <a:avLst/>
+          </a:prstGeom>
+        </p:spPr>
+      </p:pic>
+      <p:sp>
+        <p:nvSpPr>
+          <p:cNvPr id="3" name="TextBox 2"/>
+          <p:cNvSpPr txBox="1"/>
+          <p:nvPr/>
+        </p:nvSpPr>
+        <p:spPr>
+          <a:xfrm>
+            <a:off x="698500" y="571500"/>
+            <a:ext cx="9906000" cy="393700"/>
+          </a:xfrm>
+          <a:prstGeom prst="rect">
+            <a:avLst/>
+          </a:prstGeom>
+          <a:noFill/>
+        </p:spPr>
+        <p:txBody>
+          <a:bodyPr wrap="square" lIns="0" rIns="0" tIns="0" bIns="0" anchor="ctr">
+            <a:spAutoFit/>
+          </a:bodyPr>
+          <a:lstStyle/>
+          <a:p>
+            <a:pPr algn="l"/>
+            <a:r>
+              <a:rPr sz="2700" b="1">
+                <a:solidFill>
+                  <a:srgbClr val="ECECEE"/>
+                </a:solidFill>
+                <a:latin typeface="Poppins"/>
+              </a:rPr>
+              <a:t>Further questions.</a:t>
+            </a:r>
+            <a:r>
+              <a:rPr sz="2700" b="0">
+                <a:solidFill>
+                  <a:srgbClr val="9A9AA2"/>
+                </a:solidFill>
+                <a:latin typeface="Poppins"/>
+              </a:rPr>
+              <a:t> </a:t>
+            </a:r>
+          </a:p>
+        </p:txBody>
+      </p:sp>
+      <p:sp>
+        <p:nvSpPr>
+          <p:cNvPr id="4" name="TextBox 3"/>
+          <p:cNvSpPr txBox="1"/>
+          <p:nvPr/>
+        </p:nvSpPr>
+        <p:spPr>
+          <a:xfrm>
+            <a:off x="8312150" y="622300"/>
+            <a:ext cx="3175000" cy="152400"/>
+          </a:xfrm>
+          <a:prstGeom prst="rect">
+            <a:avLst/>
+          </a:prstGeom>
+          <a:noFill/>
+        </p:spPr>
+        <p:txBody>
+          <a:bodyPr wrap="square" lIns="0" rIns="0" tIns="0" bIns="0" anchor="ctr">
+            <a:spAutoFit/>
+          </a:bodyPr>
+          <a:lstStyle/>
+          <a:p>
+            <a:pPr algn="r"/>
+            <a:r>
+              <a:rPr sz="1100" b="0" spc="120">
+                <a:solidFill>
+                  <a:srgbClr val="9A9AA2"/>
+                </a:solidFill>
+                <a:latin typeface="Courier New"/>
+              </a:rPr>
+              <a:t>10 — Appendix</a:t>
             </a:r>
           </a:p>
         </p:txBody>
@@ -11477,7 +12601,7 @@
                 </a:solidFill>
                 <a:latin typeface="Courier New"/>
               </a:rPr>
-              <a:t>06 — The moat</a:t>
+              <a:t>07 — The moat</a:t>
             </a:r>
           </a:p>
         </p:txBody>

</xml_diff>